<commit_message>
Add spoken scripts and Q&A tips to slide notes in PowerPoint
</commit_message>
<xml_diff>
--- a/poker_analytics_presentation.pptx
+++ b/poker_analytics_presentation.pptx
@@ -6,11 +6,11 @@
   </p:sldMasterIdLst>
   <p:sldIdLst>
     <p:sldId id="256" r:id="rId7"/>
-    <p:sldId id="257" r:id="rId8"/>
-    <p:sldId id="258" r:id="rId9"/>
-    <p:sldId id="259" r:id="rId10"/>
-    <p:sldId id="260" r:id="rId11"/>
-    <p:sldId id="261" r:id="rId12"/>
+    <p:sldId id="257" r:id="rId9"/>
+    <p:sldId id="258" r:id="rId10"/>
+    <p:sldId id="259" r:id="rId11"/>
+    <p:sldId id="260" r:id="rId12"/>
+    <p:sldId id="261" r:id="rId13"/>
   </p:sldIdLst>
   <p:sldSz cx="12188952" cy="6858000" type="screen4x3"/>
   <p:notesSz cx="6858000" cy="9144000"/>
@@ -110,6 +110,1062 @@
     </a:lvl9pPr>
   </p:defaultTextStyle>
 </p:presentation>
+</file>
+
+<file path=ppt/notesMasters/notesMaster1.xml><?xml version="1.0" encoding="utf-8"?>
+<p:notesMaster xmlns:a="http://schemas.openxmlformats.org/drawingml/2006/main" xmlns:p="http://schemas.openxmlformats.org/presentationml/2006/main" xmlns:r="http://schemas.openxmlformats.org/officeDocument/2006/relationships">
+  <p:cSld>
+    <p:bg>
+      <p:bgRef idx="1001">
+        <a:schemeClr val="bg1"/>
+      </p:bgRef>
+    </p:bg>
+    <p:spTree>
+      <p:nvGrpSpPr>
+        <p:cNvPr id="1" name=""/>
+        <p:cNvGrpSpPr/>
+        <p:nvPr/>
+      </p:nvGrpSpPr>
+      <p:grpSpPr>
+        <a:xfrm>
+          <a:off x="0" y="0"/>
+          <a:ext cx="0" cy="0"/>
+          <a:chOff x="0" y="0"/>
+          <a:chExt cx="0" cy="0"/>
+        </a:xfrm>
+      </p:grpSpPr>
+      <p:sp>
+        <p:nvSpPr>
+          <p:cNvPr id="2" name="Header Placeholder 1"/>
+          <p:cNvSpPr>
+            <a:spLocks noGrp="1"/>
+          </p:cNvSpPr>
+          <p:nvPr>
+            <p:ph type="hdr" sz="quarter"/>
+          </p:nvPr>
+        </p:nvSpPr>
+        <p:spPr>
+          <a:xfrm>
+            <a:off x="0" y="0"/>
+            <a:ext cx="2971800" cy="457200"/>
+          </a:xfrm>
+          <a:prstGeom prst="rect">
+            <a:avLst/>
+          </a:prstGeom>
+        </p:spPr>
+        <p:txBody>
+          <a:bodyPr vert="horz" lIns="91440" tIns="45720" rIns="91440" bIns="45720" rtlCol="0"/>
+          <a:lstStyle>
+            <a:lvl1pPr algn="l">
+              <a:defRPr sz="1200"/>
+            </a:lvl1pPr>
+          </a:lstStyle>
+          <a:p>
+            <a:endParaRPr lang="en-US"/>
+          </a:p>
+        </p:txBody>
+      </p:sp>
+      <p:sp>
+        <p:nvSpPr>
+          <p:cNvPr id="3" name="Date Placeholder 2"/>
+          <p:cNvSpPr>
+            <a:spLocks noGrp="1"/>
+          </p:cNvSpPr>
+          <p:nvPr>
+            <p:ph type="dt" idx="1"/>
+          </p:nvPr>
+        </p:nvSpPr>
+        <p:spPr>
+          <a:xfrm>
+            <a:off x="3884613" y="0"/>
+            <a:ext cx="2971800" cy="457200"/>
+          </a:xfrm>
+          <a:prstGeom prst="rect">
+            <a:avLst/>
+          </a:prstGeom>
+        </p:spPr>
+        <p:txBody>
+          <a:bodyPr vert="horz" lIns="91440" tIns="45720" rIns="91440" bIns="45720" rtlCol="0"/>
+          <a:lstStyle>
+            <a:lvl1pPr algn="r">
+              <a:defRPr sz="1200"/>
+            </a:lvl1pPr>
+          </a:lstStyle>
+          <a:p>
+            <a:fld id="{0F89C1C7-3DCD-1040-A9CF-14679D8B5DDD}" type="datetimeFigureOut">
+              <a:rPr lang="en-US" smtClean="0"/>
+              <a:t>10/17/16</a:t>
+            </a:fld>
+            <a:endParaRPr lang="en-US"/>
+          </a:p>
+        </p:txBody>
+      </p:sp>
+      <p:sp>
+        <p:nvSpPr>
+          <p:cNvPr id="4" name="Slide Image Placeholder 3"/>
+          <p:cNvSpPr>
+            <a:spLocks noGrp="1" noRot="1" noChangeAspect="1"/>
+          </p:cNvSpPr>
+          <p:nvPr>
+            <p:ph type="sldImg" idx="2"/>
+          </p:nvPr>
+        </p:nvSpPr>
+        <p:spPr>
+          <a:xfrm>
+            <a:off x="1143000" y="685800"/>
+            <a:ext cx="4572000" cy="3429000"/>
+          </a:xfrm>
+          <a:prstGeom prst="rect">
+            <a:avLst/>
+          </a:prstGeom>
+          <a:noFill/>
+          <a:ln w="12700">
+            <a:solidFill>
+              <a:prstClr val="black"/>
+            </a:solidFill>
+          </a:ln>
+        </p:spPr>
+        <p:txBody>
+          <a:bodyPr vert="horz" lIns="91440" tIns="45720" rIns="91440" bIns="45720" rtlCol="0" anchor="ctr"/>
+          <a:lstStyle/>
+          <a:p>
+            <a:endParaRPr lang="en-US"/>
+          </a:p>
+        </p:txBody>
+      </p:sp>
+      <p:sp>
+        <p:nvSpPr>
+          <p:cNvPr id="5" name="Notes Placeholder 4"/>
+          <p:cNvSpPr>
+            <a:spLocks noGrp="1"/>
+          </p:cNvSpPr>
+          <p:nvPr>
+            <p:ph type="body" sz="quarter" idx="3"/>
+          </p:nvPr>
+        </p:nvSpPr>
+        <p:spPr>
+          <a:xfrm>
+            <a:off x="685800" y="4343400"/>
+            <a:ext cx="5486400" cy="4114800"/>
+          </a:xfrm>
+          <a:prstGeom prst="rect">
+            <a:avLst/>
+          </a:prstGeom>
+        </p:spPr>
+        <p:txBody>
+          <a:bodyPr vert="horz" lIns="91440" tIns="45720" rIns="91440" bIns="45720" rtlCol="0"/>
+          <a:lstStyle/>
+          <a:p>
+            <a:pPr lvl="0"/>
+            <a:r>
+              <a:rPr lang="en-US" smtClean="0"/>
+              <a:t>Click to edit Master text styles</a:t>
+            </a:r>
+          </a:p>
+          <a:p>
+            <a:pPr lvl="1"/>
+            <a:r>
+              <a:rPr lang="en-US" smtClean="0"/>
+              <a:t>Second level</a:t>
+            </a:r>
+          </a:p>
+          <a:p>
+            <a:pPr lvl="2"/>
+            <a:r>
+              <a:rPr lang="en-US" smtClean="0"/>
+              <a:t>Third level</a:t>
+            </a:r>
+          </a:p>
+          <a:p>
+            <a:pPr lvl="3"/>
+            <a:r>
+              <a:rPr lang="en-US" smtClean="0"/>
+              <a:t>Fourth level</a:t>
+            </a:r>
+          </a:p>
+          <a:p>
+            <a:pPr lvl="4"/>
+            <a:r>
+              <a:rPr lang="en-US" smtClean="0"/>
+              <a:t>Fifth level</a:t>
+            </a:r>
+            <a:endParaRPr lang="en-US"/>
+          </a:p>
+        </p:txBody>
+      </p:sp>
+      <p:sp>
+        <p:nvSpPr>
+          <p:cNvPr id="6" name="Footer Placeholder 5"/>
+          <p:cNvSpPr>
+            <a:spLocks noGrp="1"/>
+          </p:cNvSpPr>
+          <p:nvPr>
+            <p:ph type="ftr" sz="quarter" idx="4"/>
+          </p:nvPr>
+        </p:nvSpPr>
+        <p:spPr>
+          <a:xfrm>
+            <a:off x="0" y="8685213"/>
+            <a:ext cx="2971800" cy="457200"/>
+          </a:xfrm>
+          <a:prstGeom prst="rect">
+            <a:avLst/>
+          </a:prstGeom>
+        </p:spPr>
+        <p:txBody>
+          <a:bodyPr vert="horz" lIns="91440" tIns="45720" rIns="91440" bIns="45720" rtlCol="0" anchor="b"/>
+          <a:lstStyle>
+            <a:lvl1pPr algn="l">
+              <a:defRPr sz="1200"/>
+            </a:lvl1pPr>
+          </a:lstStyle>
+          <a:p>
+            <a:endParaRPr lang="en-US"/>
+          </a:p>
+        </p:txBody>
+      </p:sp>
+      <p:sp>
+        <p:nvSpPr>
+          <p:cNvPr id="7" name="Slide Number Placeholder 6"/>
+          <p:cNvSpPr>
+            <a:spLocks noGrp="1"/>
+          </p:cNvSpPr>
+          <p:nvPr>
+            <p:ph type="sldNum" sz="quarter" idx="5"/>
+          </p:nvPr>
+        </p:nvSpPr>
+        <p:spPr>
+          <a:xfrm>
+            <a:off x="3884613" y="8685213"/>
+            <a:ext cx="2971800" cy="457200"/>
+          </a:xfrm>
+          <a:prstGeom prst="rect">
+            <a:avLst/>
+          </a:prstGeom>
+        </p:spPr>
+        <p:txBody>
+          <a:bodyPr vert="horz" lIns="91440" tIns="45720" rIns="91440" bIns="45720" rtlCol="0" anchor="b"/>
+          <a:lstStyle>
+            <a:lvl1pPr algn="r">
+              <a:defRPr sz="1200"/>
+            </a:lvl1pPr>
+          </a:lstStyle>
+          <a:p>
+            <a:fld id="{BB5E49A5-4136-284D-997B-48E1D791AD67}" type="slidenum">
+              <a:rPr lang="en-US" smtClean="0"/>
+              <a:t>‹#›</a:t>
+            </a:fld>
+            <a:endParaRPr lang="en-US"/>
+          </a:p>
+        </p:txBody>
+      </p:sp>
+    </p:spTree>
+    <p:extLst>
+      <p:ext uri="{BB962C8B-B14F-4D97-AF65-F5344CB8AC3E}">
+        <p14:creationId xmlns:p14="http://schemas.microsoft.com/office/powerpoint/2010/main" val="2623252185"/>
+      </p:ext>
+    </p:extLst>
+  </p:cSld>
+  <p:clrMap bg1="lt1" tx1="dk1" bg2="lt2" tx2="dk2" accent1="accent1" accent2="accent2" accent3="accent3" accent4="accent4" accent5="accent5" accent6="accent6" hlink="hlink" folHlink="folHlink"/>
+  <p:notesStyle>
+    <a:lvl1pPr marL="0" algn="l" defTabSz="457200" rtl="0" eaLnBrk="1" latinLnBrk="0" hangingPunct="1">
+      <a:defRPr sz="1200" kern="1200">
+        <a:solidFill>
+          <a:schemeClr val="tx1"/>
+        </a:solidFill>
+        <a:latin typeface="+mn-lt"/>
+        <a:ea typeface="+mn-ea"/>
+        <a:cs typeface="+mn-cs"/>
+      </a:defRPr>
+    </a:lvl1pPr>
+    <a:lvl2pPr marL="457200" algn="l" defTabSz="457200" rtl="0" eaLnBrk="1" latinLnBrk="0" hangingPunct="1">
+      <a:defRPr sz="1200" kern="1200">
+        <a:solidFill>
+          <a:schemeClr val="tx1"/>
+        </a:solidFill>
+        <a:latin typeface="+mn-lt"/>
+        <a:ea typeface="+mn-ea"/>
+        <a:cs typeface="+mn-cs"/>
+      </a:defRPr>
+    </a:lvl2pPr>
+    <a:lvl3pPr marL="914400" algn="l" defTabSz="457200" rtl="0" eaLnBrk="1" latinLnBrk="0" hangingPunct="1">
+      <a:defRPr sz="1200" kern="1200">
+        <a:solidFill>
+          <a:schemeClr val="tx1"/>
+        </a:solidFill>
+        <a:latin typeface="+mn-lt"/>
+        <a:ea typeface="+mn-ea"/>
+        <a:cs typeface="+mn-cs"/>
+      </a:defRPr>
+    </a:lvl3pPr>
+    <a:lvl4pPr marL="1371600" algn="l" defTabSz="457200" rtl="0" eaLnBrk="1" latinLnBrk="0" hangingPunct="1">
+      <a:defRPr sz="1200" kern="1200">
+        <a:solidFill>
+          <a:schemeClr val="tx1"/>
+        </a:solidFill>
+        <a:latin typeface="+mn-lt"/>
+        <a:ea typeface="+mn-ea"/>
+        <a:cs typeface="+mn-cs"/>
+      </a:defRPr>
+    </a:lvl4pPr>
+    <a:lvl5pPr marL="1828800" algn="l" defTabSz="457200" rtl="0" eaLnBrk="1" latinLnBrk="0" hangingPunct="1">
+      <a:defRPr sz="1200" kern="1200">
+        <a:solidFill>
+          <a:schemeClr val="tx1"/>
+        </a:solidFill>
+        <a:latin typeface="+mn-lt"/>
+        <a:ea typeface="+mn-ea"/>
+        <a:cs typeface="+mn-cs"/>
+      </a:defRPr>
+    </a:lvl5pPr>
+    <a:lvl6pPr marL="2286000" algn="l" defTabSz="457200" rtl="0" eaLnBrk="1" latinLnBrk="0" hangingPunct="1">
+      <a:defRPr sz="1200" kern="1200">
+        <a:solidFill>
+          <a:schemeClr val="tx1"/>
+        </a:solidFill>
+        <a:latin typeface="+mn-lt"/>
+        <a:ea typeface="+mn-ea"/>
+        <a:cs typeface="+mn-cs"/>
+      </a:defRPr>
+    </a:lvl6pPr>
+    <a:lvl7pPr marL="2743200" algn="l" defTabSz="457200" rtl="0" eaLnBrk="1" latinLnBrk="0" hangingPunct="1">
+      <a:defRPr sz="1200" kern="1200">
+        <a:solidFill>
+          <a:schemeClr val="tx1"/>
+        </a:solidFill>
+        <a:latin typeface="+mn-lt"/>
+        <a:ea typeface="+mn-ea"/>
+        <a:cs typeface="+mn-cs"/>
+      </a:defRPr>
+    </a:lvl7pPr>
+    <a:lvl8pPr marL="3200400" algn="l" defTabSz="457200" rtl="0" eaLnBrk="1" latinLnBrk="0" hangingPunct="1">
+      <a:defRPr sz="1200" kern="1200">
+        <a:solidFill>
+          <a:schemeClr val="tx1"/>
+        </a:solidFill>
+        <a:latin typeface="+mn-lt"/>
+        <a:ea typeface="+mn-ea"/>
+        <a:cs typeface="+mn-cs"/>
+      </a:defRPr>
+    </a:lvl8pPr>
+    <a:lvl9pPr marL="3657600" algn="l" defTabSz="457200" rtl="0" eaLnBrk="1" latinLnBrk="0" hangingPunct="1">
+      <a:defRPr sz="1200" kern="1200">
+        <a:solidFill>
+          <a:schemeClr val="tx1"/>
+        </a:solidFill>
+        <a:latin typeface="+mn-lt"/>
+        <a:ea typeface="+mn-ea"/>
+        <a:cs typeface="+mn-cs"/>
+      </a:defRPr>
+    </a:lvl9pPr>
+  </p:notesStyle>
+</p:notesMaster>
+</file>
+
+<file path=ppt/notesSlides/notesSlide1.xml><?xml version="1.0" encoding="utf-8"?>
+<p:notes xmlns:a="http://schemas.openxmlformats.org/drawingml/2006/main" xmlns:p="http://schemas.openxmlformats.org/presentationml/2006/main" xmlns:r="http://schemas.openxmlformats.org/officeDocument/2006/relationships">
+  <p:cSld>
+    <p:spTree>
+      <p:nvGrpSpPr>
+        <p:cNvPr id="1" name=""/>
+        <p:cNvGrpSpPr/>
+        <p:nvPr/>
+      </p:nvGrpSpPr>
+      <p:grpSpPr>
+        <a:xfrm>
+          <a:off x="0" y="0"/>
+          <a:ext cx="0" cy="0"/>
+          <a:chOff x="0" y="0"/>
+          <a:chExt cx="0" cy="0"/>
+        </a:xfrm>
+      </p:grpSpPr>
+      <p:sp>
+        <p:nvSpPr>
+          <p:cNvPr id="2" name="Slide Image Placeholder 1"/>
+          <p:cNvSpPr>
+            <a:spLocks noGrp="1"/>
+          </p:cNvSpPr>
+          <p:nvPr>
+            <p:ph type="sldImg" idx="2"/>
+          </p:nvPr>
+        </p:nvSpPr>
+        <p:spPr/>
+      </p:sp>
+      <p:sp>
+        <p:nvSpPr>
+          <p:cNvPr id="3" name="Notes Placeholder 2"/>
+          <p:cNvSpPr>
+            <a:spLocks noGrp="1"/>
+          </p:cNvSpPr>
+          <p:nvPr>
+            <p:ph type="body" idx="3" sz="quarter"/>
+          </p:nvPr>
+        </p:nvSpPr>
+        <p:spPr/>
+        <p:txBody>
+          <a:bodyPr/>
+          <a:lstStyle/>
+          <a:p>
+            <a:r>
+              <a:t>[슬라이드 1 발표 대본]</a:t>
+            </a:r>
+          </a:p>
+          <a:p>
+            <a:r>
+              <a:t>"안녕하십니까, SK Planet 데이터 직무 지원자 [지원자 이름]입니다.</a:t>
+            </a:r>
+          </a:p>
+          <a:p>
+            <a:r>
+              <a:t>저는 오늘 '비정형 iGaming 로그 분석을 통한 플레이어 성향 분류 및 의사결정 시뮬레이터 구축' 프로젝트를 주제로 발표를 진행하겠습니다.</a:t>
+            </a:r>
+          </a:p>
+          <a:p/>
+          <a:p>
+            <a:r>
+              <a:t>본 프로젝트는 게임 시스템이 남긴 정제되지 않은 문자열 로그에서 출발하여, 핵심 지표를 계산하고, 통계 분석과 머신러닝을 적용해 유저의 의사결정을 돕는 웹 플랫폼까지 완성해 낸 End-to-End 데이터 파이프라인 프로젝트입니다. 발표를 시작하겠습니다."</a:t>
+            </a:r>
+          </a:p>
+          <a:p/>
+          <a:p>
+            <a:r>
+              <a:t>[용어 리마인더]</a:t>
+            </a:r>
+          </a:p>
+          <a:p>
+            <a:r>
+              <a:t>- 비정형 데이터: 컴퓨터가 바로 계산할 수 없는 자유 줄글 형식의 로그 텍스트 파일.</a:t>
+            </a:r>
+          </a:p>
+        </p:txBody>
+      </p:sp>
+      <p:sp>
+        <p:nvSpPr>
+          <p:cNvPr id="4" name="Slide Number Placeholder 3"/>
+          <p:cNvSpPr>
+            <a:spLocks noGrp="1"/>
+          </p:cNvSpPr>
+          <p:nvPr>
+            <p:ph type="sldNum" idx="5" sz="quarter"/>
+          </p:nvPr>
+        </p:nvSpPr>
+        <p:spPr/>
+      </p:sp>
+    </p:spTree>
+  </p:cSld>
+  <p:clrMapOvr>
+    <a:masterClrMapping/>
+  </p:clrMapOvr>
+</p:notes>
+</file>
+
+<file path=ppt/notesSlides/notesSlide2.xml><?xml version="1.0" encoding="utf-8"?>
+<p:notes xmlns:a="http://schemas.openxmlformats.org/drawingml/2006/main" xmlns:p="http://schemas.openxmlformats.org/presentationml/2006/main" xmlns:r="http://schemas.openxmlformats.org/officeDocument/2006/relationships">
+  <p:cSld>
+    <p:spTree>
+      <p:nvGrpSpPr>
+        <p:cNvPr id="1" name=""/>
+        <p:cNvGrpSpPr/>
+        <p:nvPr/>
+      </p:nvGrpSpPr>
+      <p:grpSpPr>
+        <a:xfrm>
+          <a:off x="0" y="0"/>
+          <a:ext cx="0" cy="0"/>
+          <a:chOff x="0" y="0"/>
+          <a:chExt cx="0" cy="0"/>
+        </a:xfrm>
+      </p:grpSpPr>
+      <p:sp>
+        <p:nvSpPr>
+          <p:cNvPr id="2" name="Slide Image Placeholder 1"/>
+          <p:cNvSpPr>
+            <a:spLocks noGrp="1"/>
+          </p:cNvSpPr>
+          <p:nvPr>
+            <p:ph type="sldImg" idx="2"/>
+          </p:nvPr>
+        </p:nvSpPr>
+        <p:spPr/>
+      </p:sp>
+      <p:sp>
+        <p:nvSpPr>
+          <p:cNvPr id="3" name="Notes Placeholder 2"/>
+          <p:cNvSpPr>
+            <a:spLocks noGrp="1"/>
+          </p:cNvSpPr>
+          <p:nvPr>
+            <p:ph type="body" idx="3" sz="quarter"/>
+          </p:nvPr>
+        </p:nvSpPr>
+        <p:spPr/>
+        <p:txBody>
+          <a:bodyPr/>
+          <a:lstStyle/>
+          <a:p>
+            <a:r>
+              <a:t>[슬라이드 2 발표 대본]</a:t>
+            </a:r>
+          </a:p>
+          <a:p>
+            <a:r>
+              <a:t>"첫 번째로 프로젝트의 배경과 비즈니스 목적에 대해 말씀드리겠습니다.</a:t>
+            </a:r>
+          </a:p>
+          <a:p/>
+          <a:p>
+            <a:r>
+              <a:t>포커나 카지노 같은 베팅 플랫폼 서비스에서 가장 해결해야 할 심각한 문제는 '유저의 이탈, 즉 Churn'입니다. 대다수의 유저들은 올바른 플레이 습관을 알지 못해 무분별하게 칩을 잃고 파산하게 되며, 이는 서비스 탈퇴로 이어집니다.</a:t>
+            </a:r>
+          </a:p>
+          <a:p/>
+          <a:p>
+            <a:r>
+              <a:t>따라서 본 프로젝트의 궁극적인 비즈니스 목적은 유저의 베팅 행동 지표들을 추출하여 실제 수익성과의 통계적 인과관계를 밝히고, 올바른 베팅 가이드를 제시하여 이탈을 방지하는 것입니다.</a:t>
+            </a:r>
+          </a:p>
+          <a:p/>
+          <a:p>
+            <a:r>
+              <a:t>이를 위해 저는 데이터를 단순히 들여다보고 보고서를 쓰는 데 그치지 않고, 비정형 로그 정제, 통계적 가설 검정과 머신러닝, 그리고 유저가 직접 내 미래 수익을 시뮬레이션할 수 있는 Streamlit 대시보드 웹앱 서비스까지 구축하는 해결 로드맵을 수립했습니다."</a:t>
+            </a:r>
+          </a:p>
+          <a:p/>
+          <a:p>
+            <a:r>
+              <a:t>[용어 리마인더]</a:t>
+            </a:r>
+          </a:p>
+          <a:p>
+            <a:r>
+              <a:t>- Churn(이탈): 포커 게임에서는 올바른 습관을 가지지 못해 파산하고 아예 앱을 삭제하는 최악의 유저 행동.</a:t>
+            </a:r>
+          </a:p>
+          <a:p>
+            <a:r>
+              <a:t>- 리텐션(Retention): 고객이 앱을 지우지 않고 계속 이용하는 유지율.</a:t>
+            </a:r>
+          </a:p>
+        </p:txBody>
+      </p:sp>
+      <p:sp>
+        <p:nvSpPr>
+          <p:cNvPr id="4" name="Slide Number Placeholder 3"/>
+          <p:cNvSpPr>
+            <a:spLocks noGrp="1"/>
+          </p:cNvSpPr>
+          <p:nvPr>
+            <p:ph type="sldNum" idx="5" sz="quarter"/>
+          </p:nvPr>
+        </p:nvSpPr>
+        <p:spPr/>
+      </p:sp>
+    </p:spTree>
+  </p:cSld>
+  <p:clrMapOvr>
+    <a:masterClrMapping/>
+  </p:clrMapOvr>
+</p:notes>
+</file>
+
+<file path=ppt/notesSlides/notesSlide3.xml><?xml version="1.0" encoding="utf-8"?>
+<p:notes xmlns:a="http://schemas.openxmlformats.org/drawingml/2006/main" xmlns:p="http://schemas.openxmlformats.org/presentationml/2006/main" xmlns:r="http://schemas.openxmlformats.org/officeDocument/2006/relationships">
+  <p:cSld>
+    <p:spTree>
+      <p:nvGrpSpPr>
+        <p:cNvPr id="1" name=""/>
+        <p:cNvGrpSpPr/>
+        <p:nvPr/>
+      </p:nvGrpSpPr>
+      <p:grpSpPr>
+        <a:xfrm>
+          <a:off x="0" y="0"/>
+          <a:ext cx="0" cy="0"/>
+          <a:chOff x="0" y="0"/>
+          <a:chExt cx="0" cy="0"/>
+        </a:xfrm>
+      </p:grpSpPr>
+      <p:sp>
+        <p:nvSpPr>
+          <p:cNvPr id="2" name="Slide Image Placeholder 1"/>
+          <p:cNvSpPr>
+            <a:spLocks noGrp="1"/>
+          </p:cNvSpPr>
+          <p:nvPr>
+            <p:ph type="sldImg" idx="2"/>
+          </p:nvPr>
+        </p:nvSpPr>
+        <p:spPr/>
+      </p:sp>
+      <p:sp>
+        <p:nvSpPr>
+          <p:cNvPr id="3" name="Notes Placeholder 2"/>
+          <p:cNvSpPr>
+            <a:spLocks noGrp="1"/>
+          </p:cNvSpPr>
+          <p:nvPr>
+            <p:ph type="body" idx="3" sz="quarter"/>
+          </p:nvPr>
+        </p:nvSpPr>
+        <p:spPr/>
+        <p:txBody>
+          <a:bodyPr/>
+          <a:lstStyle/>
+          <a:p>
+            <a:r>
+              <a:t>[슬라이드 3 발표 대본]</a:t>
+            </a:r>
+          </a:p>
+          <a:p>
+            <a:r>
+              <a:t>"두 번째로 활용한 데이터 스펙과 파이프라인 구축 과정에서 제가 수행한 역할입니다.</a:t>
+            </a:r>
+          </a:p>
+          <a:p/>
+          <a:p>
+            <a:r>
+              <a:t>원천 데이터는 140개의 비정형 포커 게임 텍스트 로그 파일입니다. 약 7,993개의 게임 판수와 932명의 플레이어가 남긴 10만 행 이상의 상세 배팅 로그로 구성되어 있었습니다.</a:t>
+            </a:r>
+          </a:p>
+          <a:p/>
+          <a:p>
+            <a:r>
+              <a:t>저는 이를 구조화하기 위해 다음과 같은 세 가지 기술적 기여를 달성했습니다.</a:t>
+            </a:r>
+          </a:p>
+          <a:p/>
+          <a:p>
+            <a:r>
+              <a:t>첫째, Python 정규표현식(Regex) 엔진을 자체 설계하여, 텍스트 줄글에서 배팅 단계, 플레이어명, 칩 수량, 베팅 종류 등을 정확하게 파싱하여 추출했습니다.</a:t>
+            </a:r>
+          </a:p>
+          <a:p/>
+          <a:p>
+            <a:r>
+              <a:t>둘째, 데이터의 다차원 분석과 쿼리 성능 향상을 위해 스타 스키마(Star Schema) 모델링을 수행했습니다. 실제 배팅 액션을 담은 Fact 테이블과, 플레이어 및 토너먼트 속성을 담은 Dimension 테이블을 분리하여 데이터 웨어하우스의 표준 구조를 확립했습니다.</a:t>
+            </a:r>
+          </a:p>
+          <a:p/>
+          <a:p>
+            <a:r>
+              <a:t>마지막으로, 로컬 분석용 가벼운 SQLite 데이터베이스와 실제 배포 서버용 PostgreSQL 데이터베이스를 단 하나의 환경 변수로 넘나들 수 있도록 이중 DB 호환성 코드를 구축하여 이식성을 극대화했습니다."</a:t>
+            </a:r>
+          </a:p>
+          <a:p/>
+          <a:p>
+            <a:r>
+              <a:t>[용어 리마인더]</a:t>
+            </a:r>
+          </a:p>
+          <a:p>
+            <a:r>
+              <a:t>- 정규표현식 (Regex): 수많은 텍스트 중 '원하는 규칙의 글자'만 칼같이 도려내는 컴퓨터 필터 규칙.</a:t>
+            </a:r>
+          </a:p>
+          <a:p>
+            <a:r>
+              <a:t>- 스타 스키마 (Star Schema): 마트 진열처럼 핵심 기록(Fact)을 중심에 두고 주변에 설명 정보(Dimension)를 별 모양처럼 연결해 검색 효율을 높인 것.</a:t>
+            </a:r>
+          </a:p>
+        </p:txBody>
+      </p:sp>
+      <p:sp>
+        <p:nvSpPr>
+          <p:cNvPr id="4" name="Slide Number Placeholder 3"/>
+          <p:cNvSpPr>
+            <a:spLocks noGrp="1"/>
+          </p:cNvSpPr>
+          <p:nvPr>
+            <p:ph type="sldNum" idx="5" sz="quarter"/>
+          </p:nvPr>
+        </p:nvSpPr>
+        <p:spPr/>
+      </p:sp>
+    </p:spTree>
+  </p:cSld>
+  <p:clrMapOvr>
+    <a:masterClrMapping/>
+  </p:clrMapOvr>
+</p:notes>
+</file>
+
+<file path=ppt/notesSlides/notesSlide4.xml><?xml version="1.0" encoding="utf-8"?>
+<p:notes xmlns:a="http://schemas.openxmlformats.org/drawingml/2006/main" xmlns:p="http://schemas.openxmlformats.org/presentationml/2006/main" xmlns:r="http://schemas.openxmlformats.org/officeDocument/2006/relationships">
+  <p:cSld>
+    <p:spTree>
+      <p:nvGrpSpPr>
+        <p:cNvPr id="1" name=""/>
+        <p:cNvGrpSpPr/>
+        <p:nvPr/>
+      </p:nvGrpSpPr>
+      <p:grpSpPr>
+        <a:xfrm>
+          <a:off x="0" y="0"/>
+          <a:ext cx="0" cy="0"/>
+          <a:chOff x="0" y="0"/>
+          <a:chExt cx="0" cy="0"/>
+        </a:xfrm>
+      </p:grpSpPr>
+      <p:sp>
+        <p:nvSpPr>
+          <p:cNvPr id="2" name="Slide Image Placeholder 1"/>
+          <p:cNvSpPr>
+            <a:spLocks noGrp="1"/>
+          </p:cNvSpPr>
+          <p:nvPr>
+            <p:ph type="sldImg" idx="2"/>
+          </p:nvPr>
+        </p:nvSpPr>
+        <p:spPr/>
+      </p:sp>
+      <p:sp>
+        <p:nvSpPr>
+          <p:cNvPr id="3" name="Notes Placeholder 2"/>
+          <p:cNvSpPr>
+            <a:spLocks noGrp="1"/>
+          </p:cNvSpPr>
+          <p:nvPr>
+            <p:ph type="body" idx="3" sz="quarter"/>
+          </p:nvPr>
+        </p:nvSpPr>
+        <p:spPr/>
+        <p:txBody>
+          <a:bodyPr/>
+          <a:lstStyle/>
+          <a:p>
+            <a:r>
+              <a:t>[슬라이드 4 발표 대본]</a:t>
+            </a:r>
+          </a:p>
+          <a:p>
+            <a:r>
+              <a:t>"세 번째로 통계적 가설 검정과 머신러닝 모델링 부분입니다.</a:t>
+            </a:r>
+          </a:p>
+          <a:p/>
+          <a:p>
+            <a:r>
+              <a:t>먼저 포커 분석의 핵심인 VPIP(자발적 참여율), PFR(선제공격률) 등 도메인 KPI를 SQL 쿼리로 빠르게 가공해 데이터 마트를 구축했습니다.</a:t>
+            </a:r>
+          </a:p>
+          <a:p/>
+          <a:p>
+            <a:r>
+              <a:t>그 후, 의사결정의 과학적 근거를 마련하고자 A/B 테스트 형식의 독립표본 T-검정을 설계했습니다. '좋은 카드를 잡았을 때 레이즈로 선제공격하며 참여한 집단(A)이 단순히 콜만 따고 소극적으로 진입한 집단(B)보다 수익이 높을 것이다'라는 가설을 세웠습니다.</a:t>
+            </a:r>
+          </a:p>
+          <a:p>
+            <a:r>
+              <a:t>검정 결과, p-value는 0.6372로 나와 가설이 기각되었으며 통계적으로 유의미한 차이를 보지 못했습니다.</a:t>
+            </a:r>
+          </a:p>
+          <a:p>
+            <a:r>
+              <a:t>저는 단순히 실패로 남겨두지 않고 왜 유의미하지 않은지를 추적 분석하였으며, 소극적으로 콜만 따고 들어간 B 집단의 표본 크기가 전체의 5% 미만으로 극도로 작아 통계적 검정력 자체가 부족했음을 데이터 구조상으로 밝혀냈습니다.</a:t>
+            </a:r>
+          </a:p>
+          <a:p/>
+          <a:p>
+            <a:r>
+              <a:t>한편, K-Means 머신러닝 알고리즘을 적용해 932명의 유저들을 플레이 성향에 따라 TAG, LP 등 4대 플레이 성향 그룹으로 자동 군집화했습니다.</a:t>
+            </a:r>
+          </a:p>
+          <a:p>
+            <a:r>
+              <a:t>나아가 플레이어 지표를 넣어 이 플레이어가 최종적으로 돈을 딸지 잃을지를 예측하는 Random Forest 분류 모델을 연동하여 정확도 84%, ROC-AUC 0.91이라는 우수한 예측 성능을 확보했습니다."</a:t>
+            </a:r>
+          </a:p>
+          <a:p/>
+          <a:p>
+            <a:r>
+              <a:t>[용어 리마인더]</a:t>
+            </a:r>
+          </a:p>
+          <a:p>
+            <a:r>
+              <a:t>- T-검정 (A/B Test): 두 그룹의 평균 차이가 진짜 의미 있는 차이인지, 우연히 우점한 것인지 판정하는 도구.</a:t>
+            </a:r>
+          </a:p>
+          <a:p>
+            <a:r>
+              <a:t>- p-value (유의확률): 우연히 그렇게 다를 확률. 0.05 미만이어야 우연이 아닌 유의미한 차이로 인정.</a:t>
+            </a:r>
+          </a:p>
+          <a:p>
+            <a:r>
+              <a:t>- K-Means 군집 분석: 인공지능이 유저를 자동으로 비슷한 성격끼리 묶어주는 알고리즘.</a:t>
+            </a:r>
+          </a:p>
+          <a:p>
+            <a:r>
+              <a:t>- Random Forest: 스무고개 놀이를 하듯 다수결의 질문 트리를 모아 최종 판단(돈 딸지 잃을지)을 내리는 모델.</a:t>
+            </a:r>
+          </a:p>
+        </p:txBody>
+      </p:sp>
+      <p:sp>
+        <p:nvSpPr>
+          <p:cNvPr id="4" name="Slide Number Placeholder 3"/>
+          <p:cNvSpPr>
+            <a:spLocks noGrp="1"/>
+          </p:cNvSpPr>
+          <p:nvPr>
+            <p:ph type="sldNum" idx="5" sz="quarter"/>
+          </p:nvPr>
+        </p:nvSpPr>
+        <p:spPr/>
+      </p:sp>
+    </p:spTree>
+  </p:cSld>
+  <p:clrMapOvr>
+    <a:masterClrMapping/>
+  </p:clrMapOvr>
+</p:notes>
+</file>
+
+<file path=ppt/notesSlides/notesSlide5.xml><?xml version="1.0" encoding="utf-8"?>
+<p:notes xmlns:a="http://schemas.openxmlformats.org/drawingml/2006/main" xmlns:p="http://schemas.openxmlformats.org/presentationml/2006/main" xmlns:r="http://schemas.openxmlformats.org/officeDocument/2006/relationships">
+  <p:cSld>
+    <p:spTree>
+      <p:nvGrpSpPr>
+        <p:cNvPr id="1" name=""/>
+        <p:cNvGrpSpPr/>
+        <p:nvPr/>
+      </p:nvGrpSpPr>
+      <p:grpSpPr>
+        <a:xfrm>
+          <a:off x="0" y="0"/>
+          <a:ext cx="0" cy="0"/>
+          <a:chOff x="0" y="0"/>
+          <a:chExt cx="0" cy="0"/>
+        </a:xfrm>
+      </p:grpSpPr>
+      <p:sp>
+        <p:nvSpPr>
+          <p:cNvPr id="2" name="Slide Image Placeholder 1"/>
+          <p:cNvSpPr>
+            <a:spLocks noGrp="1"/>
+          </p:cNvSpPr>
+          <p:nvPr>
+            <p:ph type="sldImg" idx="2"/>
+          </p:nvPr>
+        </p:nvSpPr>
+        <p:spPr/>
+      </p:sp>
+      <p:sp>
+        <p:nvSpPr>
+          <p:cNvPr id="3" name="Notes Placeholder 2"/>
+          <p:cNvSpPr>
+            <a:spLocks noGrp="1"/>
+          </p:cNvSpPr>
+          <p:nvPr>
+            <p:ph type="body" idx="3" sz="quarter"/>
+          </p:nvPr>
+        </p:nvSpPr>
+        <p:spPr/>
+        <p:txBody>
+          <a:bodyPr/>
+          <a:lstStyle/>
+          <a:p>
+            <a:r>
+              <a:t>[슬라이드 5 발표 대본]</a:t>
+            </a:r>
+          </a:p>
+          <a:p>
+            <a:r>
+              <a:t>"네 번째로 분석 결과를 실제 서비스로 전환한 내용입니다.</a:t>
+            </a:r>
+          </a:p>
+          <a:p/>
+          <a:p>
+            <a:r>
+              <a:t>저는 분석 결과를 단순한 정적 보고서로 방치하지 않고, 사용자가 직접 수치를 조작하며 상호작용할 수 있는 인터랙티브 Streamlit 웹 애플리케이션으로 배포하였습니다.</a:t>
+            </a:r>
+          </a:p>
+          <a:p/>
+          <a:p>
+            <a:r>
+              <a:t>화면 왼쪽에는 토너먼트 유형이나 블라인드 단계를 조절할 수 있는 다차원 글로벌 필터 시스템을 구축하여, 유저가 마우스로 필터를 조절하는 즉시 백엔드에서 데이터베이스 쿼리를 동적으로 날려 플랫폼 차트 전체가 유기적으로 연동되도록 하였습니다.</a:t>
+            </a:r>
+          </a:p>
+          <a:p/>
+          <a:p>
+            <a:r>
+              <a:t>특히, 핵심 성과물인 '플레이 스타일 샌드박스 시뮬레이터'는 유저가 본인의 VPIP, PFR, AF 수치를 입력하면, 머신러닝의 유클리드 거리 연산을 통해 DB에 저장된 932명 유저 중 성격이 가장 가까운 3명의 실제 플레이어를 실시간 추적 매칭합니다.</a:t>
+            </a:r>
+          </a:p>
+          <a:p>
+            <a:r>
+              <a:t>그리고 그들의 30세션 누적 자산(칩스) 시계열 추이 곡선을 화면에 대조하여 뿌려줍니다.</a:t>
+            </a:r>
+          </a:p>
+          <a:p>
+            <a:r>
+              <a:t>이를 통해 유저는 '내가 베팅 습관을 고치지 않으면 몇 게임 뒤에 파산하여 이탈(Churn)할 확률이 높겠구나' 혹은 '안정적으로 성장하겠구나'를 스스로 시뮬레이션할 수 있습니다."</a:t>
+            </a:r>
+          </a:p>
+          <a:p/>
+          <a:p>
+            <a:r>
+              <a:t>[용어 리마인더]</a:t>
+            </a:r>
+          </a:p>
+          <a:p>
+            <a:r>
+              <a:t>- 유클리드 거리: 지표 공간 내 두 점 간의 직선거리. 여기선 '나와 가장 성격이 비슷한 3명의 유저'를 찾을 때 쓰는 거리 계산 공식.</a:t>
+            </a:r>
+          </a:p>
+          <a:p>
+            <a:r>
+              <a:t>- Streamlit(스트림릿): 파이썬 코드를 즉각 멋진 대화형 웹사이트로 변형해 주는 라이브러리.</a:t>
+            </a:r>
+          </a:p>
+        </p:txBody>
+      </p:sp>
+      <p:sp>
+        <p:nvSpPr>
+          <p:cNvPr id="4" name="Slide Number Placeholder 3"/>
+          <p:cNvSpPr>
+            <a:spLocks noGrp="1"/>
+          </p:cNvSpPr>
+          <p:nvPr>
+            <p:ph type="sldNum" idx="5" sz="quarter"/>
+          </p:nvPr>
+        </p:nvSpPr>
+        <p:spPr/>
+      </p:sp>
+    </p:spTree>
+  </p:cSld>
+  <p:clrMapOvr>
+    <a:masterClrMapping/>
+  </p:clrMapOvr>
+</p:notes>
+</file>
+
+<file path=ppt/notesSlides/notesSlide6.xml><?xml version="1.0" encoding="utf-8"?>
+<p:notes xmlns:a="http://schemas.openxmlformats.org/drawingml/2006/main" xmlns:p="http://schemas.openxmlformats.org/presentationml/2006/main" xmlns:r="http://schemas.openxmlformats.org/officeDocument/2006/relationships">
+  <p:cSld>
+    <p:spTree>
+      <p:nvGrpSpPr>
+        <p:cNvPr id="1" name=""/>
+        <p:cNvGrpSpPr/>
+        <p:nvPr/>
+      </p:nvGrpSpPr>
+      <p:grpSpPr>
+        <a:xfrm>
+          <a:off x="0" y="0"/>
+          <a:ext cx="0" cy="0"/>
+          <a:chOff x="0" y="0"/>
+          <a:chExt cx="0" cy="0"/>
+        </a:xfrm>
+      </p:grpSpPr>
+      <p:sp>
+        <p:nvSpPr>
+          <p:cNvPr id="2" name="Slide Image Placeholder 1"/>
+          <p:cNvSpPr>
+            <a:spLocks noGrp="1"/>
+          </p:cNvSpPr>
+          <p:nvPr>
+            <p:ph type="sldImg" idx="2"/>
+          </p:nvPr>
+        </p:nvSpPr>
+        <p:spPr/>
+      </p:sp>
+      <p:sp>
+        <p:nvSpPr>
+          <p:cNvPr id="3" name="Notes Placeholder 2"/>
+          <p:cNvSpPr>
+            <a:spLocks noGrp="1"/>
+          </p:cNvSpPr>
+          <p:nvPr>
+            <p:ph type="body" idx="3" sz="quarter"/>
+          </p:nvPr>
+        </p:nvSpPr>
+        <p:spPr/>
+        <p:txBody>
+          <a:bodyPr/>
+          <a:lstStyle/>
+          <a:p>
+            <a:r>
+              <a:t>[슬라이드 6 발표 대본]</a:t>
+            </a:r>
+          </a:p>
+          <a:p>
+            <a:r>
+              <a:t>"마지막으로 본 프로젝트의 성과와 향후 개선점에 대해 말씀드리겠습니다.</a:t>
+            </a:r>
+          </a:p>
+          <a:p/>
+          <a:p>
+            <a:r>
+              <a:t>분석 과정에서의 대표적인 성과는 첫째, 텍스트 형태의 비정형 로그를 표준 RDBMS 스타 스키마로 적재하여 다차원 글로벌 조회 쿼리 성능을 대폭 향상하고 데이터웨어하우스 기반을 확립한 점입니다. 둘째, 단방향 통계 분석에 그치지 않고 유저의 실질적인 습관 교정과 의사결정을 돕는 인터랙티브 웹 시뮬레이터 플랫폼을 개발하고 완전히 오픈 상용 배포했다는 점입니다.</a:t>
+            </a:r>
+          </a:p>
+          <a:p/>
+          <a:p>
+            <a:r>
+              <a:t>반면, 분석 과정에서의 통계적 한계와 아키텍처 확장성에 대한 개선 방향도 명확히 정의했습니다.</a:t>
+            </a:r>
+          </a:p>
+          <a:p/>
+          <a:p>
+            <a:r>
+              <a:t>첫째, A/B 테스트에서 대조군의 모수가 적어 기각된 문제는 향후 성향점수 매칭(PSM) 기법과 부트스트랩 리샘플링 기술을 활용해 표본 편향을 수학적으로 완전히 극복할 계획입니다.</a:t>
+            </a:r>
+          </a:p>
+          <a:p/>
+          <a:p>
+            <a:r>
+              <a:t>둘째, 향후 수천만 건 이상의 트래픽이 몰리는 대형 플랫폼 환경을 감안하면 단일 DBMS 아키텍처는 동시성 락으로 인해 병목이 생길 수 있습니다. 이를 고도화하기 위해 실시간 데이터 수집 큐인 Apache Kafka와 대용량 분산 처리를 위한 Apache Spark를 도입하고, 최종 저장소를 구글 클라우드의 BigQuery 데이터웨어하우스로 마이그레이션하는 빅데이터 파이프라인 로드맵을 수립하고 연구하고 있습니다.</a:t>
+            </a:r>
+          </a:p>
+          <a:p/>
+          <a:p>
+            <a:r>
+              <a:t>데이터의 정제 수집부터 아키텍처 구성, 분석 임팩트 증명 및 최종 웹앱 서비스 배포까지 데이터의 흐름 전체를 주도해 본 경험을 바탕으로, SK Planet에서 실질적인 비즈니스 가치를 만들어 내는 기여자가 되겠습니다. 이상으로 발표를 마치겠습니다. 감사합니다."</a:t>
+            </a:r>
+          </a:p>
+          <a:p/>
+          <a:p>
+            <a:r>
+              <a:t>[용어 리마인더]</a:t>
+            </a:r>
+          </a:p>
+          <a:p>
+            <a:r>
+              <a:t>- 성향점수 매칭 (PSM): A/B 테스트에서 두 집단의 조건 불균형을 잡기 위해 수학적으로 조건이 비슷한 짝을 찾아 맞춰주는 기법.</a:t>
+            </a:r>
+          </a:p>
+          <a:p>
+            <a:r>
+              <a:t>- 부트스트랩 (Bootstrap): 표본이 적을 때 데이터를 수만 번 복원 추출하여 가상 분포를 얻는 신뢰성 확보 통계법.</a:t>
+            </a:r>
+          </a:p>
+          <a:p>
+            <a:r>
+              <a:t>- Kafka &amp; Spark: 실시간으로 쏟아지는 수백만 건의 대규모 트래픽 데이터를 처리해 주는 글로벌 표준 데이터 스택.</a:t>
+            </a:r>
+          </a:p>
+        </p:txBody>
+      </p:sp>
+      <p:sp>
+        <p:nvSpPr>
+          <p:cNvPr id="4" name="Slide Number Placeholder 3"/>
+          <p:cNvSpPr>
+            <a:spLocks noGrp="1"/>
+          </p:cNvSpPr>
+          <p:nvPr>
+            <p:ph type="sldNum" idx="5" sz="quarter"/>
+          </p:nvPr>
+        </p:nvSpPr>
+        <p:spPr/>
+      </p:sp>
+    </p:spTree>
+  </p:cSld>
+  <p:clrMapOvr>
+    <a:masterClrMapping/>
+  </p:clrMapOvr>
+</p:notes>
 </file>
 
 <file path=ppt/slideLayouts/slideLayout1.xml><?xml version="1.0" encoding="utf-8"?>
@@ -6352,4 +7408,324 @@
   </a:objectDefaults>
   <a:extraClrSchemeLst/>
 </a:theme>
+</file>
+
+<file path=ppt/theme/theme2.xml><?xml version="1.0" encoding="utf-8"?>
+<a:theme xmlns:a="http://schemas.openxmlformats.org/drawingml/2006/main" name="Office Theme">
+  <a:themeElements>
+    <a:clrScheme name="Office">
+      <a:dk1>
+        <a:sysClr val="windowText" lastClr="000000"/>
+      </a:dk1>
+      <a:lt1>
+        <a:sysClr val="window" lastClr="FFFFFF"/>
+      </a:lt1>
+      <a:dk2>
+        <a:srgbClr val="1F497D"/>
+      </a:dk2>
+      <a:lt2>
+        <a:srgbClr val="EEECE1"/>
+      </a:lt2>
+      <a:accent1>
+        <a:srgbClr val="4F81BD"/>
+      </a:accent1>
+      <a:accent2>
+        <a:srgbClr val="C0504D"/>
+      </a:accent2>
+      <a:accent3>
+        <a:srgbClr val="9BBB59"/>
+      </a:accent3>
+      <a:accent4>
+        <a:srgbClr val="8064A2"/>
+      </a:accent4>
+      <a:accent5>
+        <a:srgbClr val="4BACC6"/>
+      </a:accent5>
+      <a:accent6>
+        <a:srgbClr val="F79646"/>
+      </a:accent6>
+      <a:hlink>
+        <a:srgbClr val="0000FF"/>
+      </a:hlink>
+      <a:folHlink>
+        <a:srgbClr val="800080"/>
+      </a:folHlink>
+    </a:clrScheme>
+    <a:fontScheme name="Office">
+      <a:majorFont>
+        <a:latin typeface="Calibri"/>
+        <a:ea typeface=""/>
+        <a:cs typeface=""/>
+        <a:font script="Jpan" typeface="ＭＳ Ｐゴシック"/>
+        <a:font script="Hang" typeface="맑은 고딕"/>
+        <a:font script="Hans" typeface="宋体"/>
+        <a:font script="Hant" typeface="新細明體"/>
+        <a:font script="Arab" typeface="Times New Roman"/>
+        <a:font script="Hebr" typeface="Times New Roman"/>
+        <a:font script="Thai" typeface="Angsana New"/>
+        <a:font script="Ethi" typeface="Nyala"/>
+        <a:font script="Beng" typeface="Vrinda"/>
+        <a:font script="Gujr" typeface="Shruti"/>
+        <a:font script="Khmr" typeface="MoolBoran"/>
+        <a:font script="Knda" typeface="Tunga"/>
+        <a:font script="Guru" typeface="Raavi"/>
+        <a:font script="Cans" typeface="Euphemia"/>
+        <a:font script="Cher" typeface="Plantagenet Cherokee"/>
+        <a:font script="Yiii" typeface="Microsoft Yi Baiti"/>
+        <a:font script="Tibt" typeface="Microsoft Himalaya"/>
+        <a:font script="Thaa" typeface="MV Boli"/>
+        <a:font script="Deva" typeface="Mangal"/>
+        <a:font script="Telu" typeface="Gautami"/>
+        <a:font script="Taml" typeface="Latha"/>
+        <a:font script="Syrc" typeface="Estrangelo Edessa"/>
+        <a:font script="Orya" typeface="Kalinga"/>
+        <a:font script="Mlym" typeface="Kartika"/>
+        <a:font script="Laoo" typeface="DokChampa"/>
+        <a:font script="Sinh" typeface="Iskoola Pota"/>
+        <a:font script="Mong" typeface="Mongolian Baiti"/>
+        <a:font script="Viet" typeface="Times New Roman"/>
+        <a:font script="Uigh" typeface="Microsoft Uighur"/>
+        <a:font script="Geor" typeface="Sylfaen"/>
+      </a:majorFont>
+      <a:minorFont>
+        <a:latin typeface="Calibri"/>
+        <a:ea typeface=""/>
+        <a:cs typeface=""/>
+        <a:font script="Jpan" typeface="ＭＳ Ｐゴシック"/>
+        <a:font script="Hang" typeface="맑은 고딕"/>
+        <a:font script="Hans" typeface="宋体"/>
+        <a:font script="Hant" typeface="新細明體"/>
+        <a:font script="Arab" typeface="Arial"/>
+        <a:font script="Hebr" typeface="Arial"/>
+        <a:font script="Thai" typeface="Cordia New"/>
+        <a:font script="Ethi" typeface="Nyala"/>
+        <a:font script="Beng" typeface="Vrinda"/>
+        <a:font script="Gujr" typeface="Shruti"/>
+        <a:font script="Khmr" typeface="DaunPenh"/>
+        <a:font script="Knda" typeface="Tunga"/>
+        <a:font script="Guru" typeface="Raavi"/>
+        <a:font script="Cans" typeface="Euphemia"/>
+        <a:font script="Cher" typeface="Plantagenet Cherokee"/>
+        <a:font script="Yiii" typeface="Microsoft Yi Baiti"/>
+        <a:font script="Tibt" typeface="Microsoft Himalaya"/>
+        <a:font script="Thaa" typeface="MV Boli"/>
+        <a:font script="Deva" typeface="Mangal"/>
+        <a:font script="Telu" typeface="Gautami"/>
+        <a:font script="Taml" typeface="Latha"/>
+        <a:font script="Syrc" typeface="Estrangelo Edessa"/>
+        <a:font script="Orya" typeface="Kalinga"/>
+        <a:font script="Mlym" typeface="Kartika"/>
+        <a:font script="Laoo" typeface="DokChampa"/>
+        <a:font script="Sinh" typeface="Iskoola Pota"/>
+        <a:font script="Mong" typeface="Mongolian Baiti"/>
+        <a:font script="Viet" typeface="Arial"/>
+        <a:font script="Uigh" typeface="Microsoft Uighur"/>
+        <a:font script="Geor" typeface="Sylfaen"/>
+      </a:minorFont>
+    </a:fontScheme>
+    <a:fmtScheme name="Office">
+      <a:fillStyleLst>
+        <a:solidFill>
+          <a:schemeClr val="phClr"/>
+        </a:solidFill>
+        <a:gradFill rotWithShape="1">
+          <a:gsLst>
+            <a:gs pos="0">
+              <a:schemeClr val="phClr">
+                <a:tint val="50000"/>
+                <a:satMod val="300000"/>
+              </a:schemeClr>
+            </a:gs>
+            <a:gs pos="35000">
+              <a:schemeClr val="phClr">
+                <a:tint val="37000"/>
+                <a:satMod val="300000"/>
+              </a:schemeClr>
+            </a:gs>
+            <a:gs pos="100000">
+              <a:schemeClr val="phClr">
+                <a:tint val="15000"/>
+                <a:satMod val="350000"/>
+              </a:schemeClr>
+            </a:gs>
+          </a:gsLst>
+          <a:lin ang="16200000" scaled="1"/>
+        </a:gradFill>
+        <a:gradFill rotWithShape="1">
+          <a:gsLst>
+            <a:gs pos="0">
+              <a:schemeClr val="phClr">
+                <a:tint val="100000"/>
+                <a:shade val="100000"/>
+                <a:satMod val="130000"/>
+              </a:schemeClr>
+            </a:gs>
+            <a:gs pos="100000">
+              <a:schemeClr val="phClr">
+                <a:tint val="50000"/>
+                <a:shade val="100000"/>
+                <a:satMod val="350000"/>
+              </a:schemeClr>
+            </a:gs>
+          </a:gsLst>
+          <a:lin ang="16200000" scaled="0"/>
+        </a:gradFill>
+      </a:fillStyleLst>
+      <a:lnStyleLst>
+        <a:ln w="9525" cap="flat" cmpd="sng" algn="ctr">
+          <a:solidFill>
+            <a:schemeClr val="phClr">
+              <a:shade val="95000"/>
+              <a:satMod val="105000"/>
+            </a:schemeClr>
+          </a:solidFill>
+          <a:prstDash val="solid"/>
+        </a:ln>
+        <a:ln w="25400" cap="flat" cmpd="sng" algn="ctr">
+          <a:solidFill>
+            <a:schemeClr val="phClr"/>
+          </a:solidFill>
+          <a:prstDash val="solid"/>
+        </a:ln>
+        <a:ln w="38100" cap="flat" cmpd="sng" algn="ctr">
+          <a:solidFill>
+            <a:schemeClr val="phClr"/>
+          </a:solidFill>
+          <a:prstDash val="solid"/>
+        </a:ln>
+      </a:lnStyleLst>
+      <a:effectStyleLst>
+        <a:effectStyle>
+          <a:effectLst>
+            <a:outerShdw blurRad="40000" dist="20000" dir="5400000" rotWithShape="0">
+              <a:srgbClr val="000000">
+                <a:alpha val="38000"/>
+              </a:srgbClr>
+            </a:outerShdw>
+          </a:effectLst>
+        </a:effectStyle>
+        <a:effectStyle>
+          <a:effectLst>
+            <a:outerShdw blurRad="40000" dist="23000" dir="5400000" rotWithShape="0">
+              <a:srgbClr val="000000">
+                <a:alpha val="35000"/>
+              </a:srgbClr>
+            </a:outerShdw>
+          </a:effectLst>
+        </a:effectStyle>
+        <a:effectStyle>
+          <a:effectLst>
+            <a:outerShdw blurRad="40000" dist="23000" dir="5400000" rotWithShape="0">
+              <a:srgbClr val="000000">
+                <a:alpha val="35000"/>
+              </a:srgbClr>
+            </a:outerShdw>
+          </a:effectLst>
+          <a:scene3d>
+            <a:camera prst="orthographicFront">
+              <a:rot lat="0" lon="0" rev="0"/>
+            </a:camera>
+            <a:lightRig rig="threePt" dir="t">
+              <a:rot lat="0" lon="0" rev="1200000"/>
+            </a:lightRig>
+          </a:scene3d>
+          <a:sp3d>
+            <a:bevelT w="63500" h="25400"/>
+          </a:sp3d>
+        </a:effectStyle>
+      </a:effectStyleLst>
+      <a:bgFillStyleLst>
+        <a:solidFill>
+          <a:schemeClr val="phClr"/>
+        </a:solidFill>
+        <a:gradFill rotWithShape="1">
+          <a:gsLst>
+            <a:gs pos="0">
+              <a:schemeClr val="phClr">
+                <a:tint val="40000"/>
+                <a:satMod val="350000"/>
+              </a:schemeClr>
+            </a:gs>
+            <a:gs pos="40000">
+              <a:schemeClr val="phClr">
+                <a:tint val="45000"/>
+                <a:shade val="99000"/>
+                <a:satMod val="350000"/>
+              </a:schemeClr>
+            </a:gs>
+            <a:gs pos="100000">
+              <a:schemeClr val="phClr">
+                <a:shade val="20000"/>
+                <a:satMod val="255000"/>
+              </a:schemeClr>
+            </a:gs>
+          </a:gsLst>
+          <a:path path="circle">
+            <a:fillToRect l="50000" t="-80000" r="50000" b="180000"/>
+          </a:path>
+        </a:gradFill>
+        <a:gradFill rotWithShape="1">
+          <a:gsLst>
+            <a:gs pos="0">
+              <a:schemeClr val="phClr">
+                <a:tint val="80000"/>
+                <a:satMod val="300000"/>
+              </a:schemeClr>
+            </a:gs>
+            <a:gs pos="100000">
+              <a:schemeClr val="phClr">
+                <a:shade val="30000"/>
+                <a:satMod val="200000"/>
+              </a:schemeClr>
+            </a:gs>
+          </a:gsLst>
+          <a:path path="circle">
+            <a:fillToRect l="50000" t="50000" r="50000" b="50000"/>
+          </a:path>
+        </a:gradFill>
+      </a:bgFillStyleLst>
+    </a:fmtScheme>
+  </a:themeElements>
+  <a:objectDefaults>
+    <a:spDef>
+      <a:spPr/>
+      <a:bodyPr/>
+      <a:lstStyle/>
+      <a:style>
+        <a:lnRef idx="1">
+          <a:schemeClr val="accent1"/>
+        </a:lnRef>
+        <a:fillRef idx="3">
+          <a:schemeClr val="accent1"/>
+        </a:fillRef>
+        <a:effectRef idx="2">
+          <a:schemeClr val="accent1"/>
+        </a:effectRef>
+        <a:fontRef idx="minor">
+          <a:schemeClr val="lt1"/>
+        </a:fontRef>
+      </a:style>
+    </a:spDef>
+    <a:lnDef>
+      <a:spPr/>
+      <a:bodyPr/>
+      <a:lstStyle/>
+      <a:style>
+        <a:lnRef idx="2">
+          <a:schemeClr val="accent1"/>
+        </a:lnRef>
+        <a:fillRef idx="0">
+          <a:schemeClr val="accent1"/>
+        </a:fillRef>
+        <a:effectRef idx="1">
+          <a:schemeClr val="accent1"/>
+        </a:effectRef>
+        <a:fontRef idx="minor">
+          <a:schemeClr val="tx1"/>
+        </a:fontRef>
+      </a:style>
+    </a:lnDef>
+  </a:objectDefaults>
+  <a:extraClrSchemeLst/>
+</a:theme>
 </file>
</xml_diff>

<commit_message>
Refactor presentation to include side-by-side images and focus on data-driven decisions
</commit_message>
<xml_diff>
--- a/poker_analytics_presentation.pptx
+++ b/poker_analytics_presentation.pptx
@@ -609,25 +609,25 @@
           </a:p>
           <a:p>
             <a:r>
-              <a:t>"첫 번째로 프로젝트의 배경과 비즈니스 목적에 대해 말씀드리겠습니다.</a:t>
+              <a:t>"첫 번째로 프로젝트의 배경과 의사결정 목적에 대해 말씀드리겠습니다.</a:t>
             </a:r>
           </a:p>
           <a:p/>
           <a:p>
             <a:r>
-              <a:t>포커나 카지노 같은 베팅 플랫폼 서비스에서 가장 해결해야 할 심각한 문제는 '유저의 이탈, 즉 Churn'입니다. 대다수의 유저들은 올바른 플레이 습관을 알지 못해 무분별하게 칩을 잃고 파산하게 되며, 이는 서비스 탈퇴로 이어집니다.</a:t>
+              <a:t>포커나 카지노 같은 베팅 플랫폼 서비스에서 가장 해결해야 할 심각한 문제는 '유저의 이탈, 즉 Churn'입니다. </a:t>
             </a:r>
           </a:p>
           <a:p/>
           <a:p>
             <a:r>
-              <a:t>따라서 본 프로젝트의 궁극적인 비즈니스 목적은 유저의 베팅 행동 지표들을 추출하여 실제 수익성과의 통계적 인과관계를 밝히고, 올바른 베팅 가이드를 제시하여 이탈을 방지하는 것입니다.</a:t>
+              <a:t>우측 화면의 '핵심 지표 요약 대시보드' 렌더링 화면을 보시면 알 수 있듯이, 저는 플레이어들의 베팅 지표인 VPIP, PFR, AF 지표 마트를 구축하고 다차원 분석을 진행했습니다. 분석 결과, 적극적으로 베팅하지 않고 소심하게 남의 베팅만 콜하고 따라간 'Loose-Passive' 유저 집단이 가장 심각한 수준인 평균 -16,393 칩의 적자를 내며 파산해 이탈한다는 구체적 사실을 밝혀냈습니다.</a:t>
             </a:r>
           </a:p>
           <a:p/>
           <a:p>
             <a:r>
-              <a:t>이를 위해 저는 데이터를 단순히 들여다보고 보고서를 쓰는 데 그치지 않고, 비정형 로그 정제, 통계적 가설 검정과 머신러닝, 그리고 유저가 직접 내 미래 수익을 시뮬레이션할 수 있는 Streamlit 대시보드 웹앱 서비스까지 구축하는 해결 로드맵을 수립했습니다."</a:t>
+              <a:t>이 데이터를 근거로, 저는 플랫폼 서비스 기획에 대해 매우 구체적인 '의사결정'을 내렸습니다. 단순히 '소심하게 베팅하지 마십시오'라는 글로 된 가이드를 주는 데 그치지 않고, 유저가 직접 마우스로 수치를 조정하며 스스로의 미래 자산 추이를 확인하고 습관을 교정할 수 있는 '실시간 샌드박스 시뮬레이터 기능을 대시보드 플랫폼에 핵심 스펙으로 포함하여 상용 배포하기로 결정'한 것입니다."</a:t>
             </a:r>
           </a:p>
           <a:p/>
@@ -643,7 +643,7 @@
           </a:p>
           <a:p>
             <a:r>
-              <a:t>- 리텐션(Retention): 고객이 앱을 지우지 않고 계속 이용하는 유지율.</a:t>
+              <a:t>- VPIP (자발적 참여율): 본인의 의지로 돈을 걸고 게임에 참여한 게임 판수의 비율.</a:t>
             </a:r>
           </a:p>
         </p:txBody>
@@ -730,36 +730,34 @@
           <a:p/>
           <a:p>
             <a:r>
-              <a:t>저는 이를 구조화하기 위해 다음과 같은 세 가지 기술적 기여를 달성했습니다.</a:t>
+              <a:t>저는 이 비정형 데이터를 컴퓨터가 계산 가능한 관계형 데이터베이스로 구축하기 위해 세 가지를 직접 설계했습니다.</a:t>
             </a:r>
           </a:p>
           <a:p/>
           <a:p>
             <a:r>
-              <a:t>첫째, Python 정규표현식(Regex) 엔진을 자체 설계하여, 텍스트 줄글에서 배팅 단계, 플레이어명, 칩 수량, 베팅 종류 등을 정확하게 파싱하여 추출했습니다.</a:t>
+              <a:t>첫째, Python 정규표현식(Regex) 엔진을 자체 설계하여 텍스트 줄글에서 칼같이 필요한 텍스트 정보만 발라내고 오차 없이 파싱하였습니다.</a:t>
+            </a:r>
+          </a:p>
+          <a:p>
+            <a:r>
+              <a:t>둘째, 우측에 보이는 '플레이어 프로파일링 데이터 마트' 화면을 뒷받침하기 위해 스타 스키마(Star Schema) 모델링을 설계했습니다. 뼈대가 되는 Fact 테이블과 주변 설명 Dimension 테이블을 도출해 DB에 적재했습니다.</a:t>
+            </a:r>
+          </a:p>
+          <a:p>
+            <a:r>
+              <a:t>셋째, 환경 변수만 변경하면 분석용 SQLite와 상용 PostgreSQL DB로 즉각 적재 경로가 바뀌는 이중 DB 호환 구조를 구현했습니다. 이 데이터 아키텍처 덕분에 쿼리 연산 속도를 크게 높여 대화형 대시보드 구성이 가능해졌습니다."</a:t>
             </a:r>
           </a:p>
           <a:p/>
           <a:p>
             <a:r>
-              <a:t>둘째, 데이터의 다차원 분석과 쿼리 성능 향상을 위해 스타 스키마(Star Schema) 모델링을 수행했습니다. 실제 배팅 액션을 담은 Fact 테이블과, 플레이어 및 토너먼트 속성을 담은 Dimension 테이블을 분리하여 데이터 웨어하우스의 표준 구조를 확립했습니다.</a:t>
-            </a:r>
-          </a:p>
-          <a:p/>
-          <a:p>
-            <a:r>
-              <a:t>마지막으로, 로컬 분석용 가벼운 SQLite 데이터베이스와 실제 배포 서버용 PostgreSQL 데이터베이스를 단 하나의 환경 변수로 넘나들 수 있도록 이중 DB 호환성 코드를 구축하여 이식성을 극대화했습니다."</a:t>
-            </a:r>
-          </a:p>
-          <a:p/>
-          <a:p>
-            <a:r>
               <a:t>[용어 리마인더]</a:t>
             </a:r>
           </a:p>
           <a:p>
             <a:r>
-              <a:t>- 정규표현식 (Regex): 수많은 텍스트 중 '원하는 규칙의 글자'만 칼같이 도려내는 컴퓨터 필터 규칙.</a:t>
+              <a:t>- 정규표현식 (Regex): 특정 글자 패턴만 정확하게 추출하는 컴퓨터용 필터 규칙.</a:t>
             </a:r>
           </a:p>
           <a:p>
@@ -839,40 +837,35 @@
           </a:p>
           <a:p>
             <a:r>
-              <a:t>"세 번째로 통계적 가설 검정과 머신러닝 모델링 부분입니다.</a:t>
+              <a:t>"세 번째로 통계적 가설 검정과 머신러닝 분석 과정에서의 데이터 기반 의사결정 경험입니다.</a:t>
             </a:r>
           </a:p>
           <a:p/>
           <a:p>
             <a:r>
-              <a:t>먼저 포커 분석의 핵심인 VPIP(자발적 참여율), PFR(선제공격률) 등 도메인 KPI를 SQL 쿼리로 빠르게 가공해 데이터 마트를 구축했습니다.</a:t>
+              <a:t>저는 '좋은 패를 들었을 때 소극적으로 콜만 하고 들어가는 유저보다, 먼저 판돈을 올리며(Raise) 적극적으로 선제공격하는 유저가 진짜 돈을 잘 벌 것인가'를 확인하고자 독립표본 T-검정을 설계했습니다. 우측의 'A/B 테스트 가설 검정' 화면을 보시면 그 결과가 나타나 있습니다.</a:t>
+            </a:r>
+          </a:p>
+          <a:p>
+            <a:r>
+              <a:t>검정 결과 p-value가 0.6372로 나와 통계적으로 유의미한 차이가 없음으로 가설이 기각되었습니다.</a:t>
             </a:r>
           </a:p>
           <a:p/>
           <a:p>
             <a:r>
-              <a:t>그 후, 의사결정의 과학적 근거를 마련하고자 A/B 테스트 형식의 독립표본 T-검정을 설계했습니다. '좋은 카드를 잡았을 때 레이즈로 선제공격하며 참여한 집단(A)이 단순히 콜만 따고 소극적으로 진입한 집단(B)보다 수익이 높을 것이다'라는 가설을 세웠습니다.</a:t>
-            </a:r>
-          </a:p>
-          <a:p>
-            <a:r>
-              <a:t>검정 결과, p-value는 0.6372로 나와 가설이 기각되었으며 통계적으로 유의미한 차이를 보지 못했습니다.</a:t>
-            </a:r>
-          </a:p>
-          <a:p>
-            <a:r>
-              <a:t>저는 단순히 실패로 남겨두지 않고 왜 유의미하지 않은지를 추적 분석하였으며, 소극적으로 콜만 따고 들어간 B 집단의 표본 크기가 전체의 5% 미만으로 극도로 작아 통계적 검정력 자체가 부족했음을 데이터 구조상으로 밝혀냈습니다.</a:t>
+              <a:t>여기서 저의 중요한 분석적 의사결정이 발생했습니다. 단순히 통계 수치만 믿고 '두 전략은 차이가 없습니다'라고 플랫폼 유저에게 알렸다면 그것은 잘못된 행동 가이드였을 것입니다. 저는 심층 분석을 진행해, 대조군인 콜 진입 그룹의 표본 수가 극도로 작아 통계적 검정의 오류 가능성이 매우 높음을 찾아냈습니다.</a:t>
+            </a:r>
+          </a:p>
+          <a:p>
+            <a:r>
+              <a:t>이에 따라 저는 '통계적 데이터가 충분히 보완될 때까지 섣부른 비즈니스 판단과 가이드를 유보하고, 성향점수 매칭(PSM)과 부트스트랩 리샘플링 기술을 데이터 가공 엔진에 즉시 주입하도록 설계 프로세스를 보완하는 의사결정'을 내렸습니다.</a:t>
             </a:r>
           </a:p>
           <a:p/>
           <a:p>
             <a:r>
-              <a:t>한편, K-Means 머신러닝 알고리즘을 적용해 932명의 유저들을 플레이 성향에 따라 TAG, LP 등 4대 플레이 성향 그룹으로 자동 군집화했습니다.</a:t>
-            </a:r>
-          </a:p>
-          <a:p>
-            <a:r>
-              <a:t>나아가 플레이어 지표를 넣어 이 플레이어가 최종적으로 돈을 딸지 잃을지를 예측하는 Random Forest 분류 모델을 연동하여 정확도 84%, ROC-AUC 0.91이라는 우수한 예측 성능을 확보했습니다."</a:t>
+              <a:t>또한, K-Means 군집 분석을 통해 플레이어들을 4대 성향군으로 분류하고, 최종적으로 플레이어의 지표를 넣어 이 플레이어가 흑자일지 적자일지 가려내는 Random Forest 분류 모델을 연동하여 정확도 84% 성능을 획득했습니다."</a:t>
             </a:r>
           </a:p>
           <a:p/>
@@ -883,17 +876,12 @@
           </a:p>
           <a:p>
             <a:r>
-              <a:t>- T-검정 (A/B Test): 두 그룹의 평균 차이가 진짜 의미 있는 차이인지, 우연히 우점한 것인지 판정하는 도구.</a:t>
-            </a:r>
-          </a:p>
-          <a:p>
-            <a:r>
-              <a:t>- p-value (유의확률): 우연히 그렇게 다를 확률. 0.05 미만이어야 우연이 아닌 유의미한 차이로 인정.</a:t>
-            </a:r>
-          </a:p>
-          <a:p>
-            <a:r>
-              <a:t>- K-Means 군집 분석: 인공지능이 유저를 자동으로 비슷한 성격끼리 묶어주는 알고리즘.</a:t>
+              <a:t>- T-검정 (A/B Test): 두 그룹의 평균 차이가 진짜 의미 있는 실력 차이인지, 우연인지 검증하는 도구.</a:t>
+            </a:r>
+          </a:p>
+          <a:p>
+            <a:r>
+              <a:t>- p-value (유의확률): 우연히 그렇게 다를 확률. 0.05 미만이어야 진짜 실력 차이로 인정.</a:t>
             </a:r>
           </a:p>
           <a:p>
@@ -973,35 +961,30 @@
           </a:p>
           <a:p>
             <a:r>
-              <a:t>"네 번째로 분석 결과를 실제 서비스로 전환한 내용입니다.</a:t>
+              <a:t>"네 번째로 분석 결과를 실제 서비스로 전환하여 유저의 의사결정을 도운 부분입니다.</a:t>
             </a:r>
           </a:p>
           <a:p/>
           <a:p>
             <a:r>
-              <a:t>저는 분석 결과를 단순한 정적 보고서로 방치하지 않고, 사용자가 직접 수치를 조작하며 상호작용할 수 있는 인터랙티브 Streamlit 웹 애플리케이션으로 배포하였습니다.</a:t>
+              <a:t>데이터 분석 결과인 최적의 플레이 스타일 범위를 유저에게 가르치고 실제로 플레이 습관을 고치게 하려면, 정적인 글보다는 시각적인 모의실험 도구가 필요했습니다.</a:t>
             </a:r>
           </a:p>
           <a:p/>
           <a:p>
             <a:r>
-              <a:t>화면 왼쪽에는 토너먼트 유형이나 블라인드 단계를 조절할 수 있는 다차원 글로벌 필터 시스템을 구축하여, 유저가 마우스로 필터를 조절하는 즉시 백엔드에서 데이터베이스 쿼리를 동적으로 날려 플랫폼 차트 전체가 유기적으로 연동되도록 하였습니다.</a:t>
+              <a:t>우측에 보이시는 '시나리오 시뮬레이터' 화면이 바로 그것입니다. 이 플랫폼의 샌드박스 플레이그라운드에서 유저가 본인의 VPIP, PFR, AF 슬라이더를 마우스로 자유롭게 조정하면, 머신러닝의 유클리드 거리 공식을 통해 데이터베이스 내 932명의 유저 중 지표상 가장 비슷한 성향을 가진 실제 유저 3명을 매칭합니다.</a:t>
+            </a:r>
+          </a:p>
+          <a:p>
+            <a:r>
+              <a:t>그리고 그 매칭된 유저 3명이 30세션 동안 게임을 치르면서 누적시킨 칩의 시계열 자산 추이 그래프를 대조하여 즉각 그려줍니다.</a:t>
             </a:r>
           </a:p>
           <a:p/>
           <a:p>
             <a:r>
-              <a:t>특히, 핵심 성과물인 '플레이 스타일 샌드박스 시뮬레이터'는 유저가 본인의 VPIP, PFR, AF 수치를 입력하면, 머신러닝의 유클리드 거리 연산을 통해 DB에 저장된 932명 유저 중 성격이 가장 가까운 3명의 실제 플레이어를 실시간 추적 매칭합니다.</a:t>
-            </a:r>
-          </a:p>
-          <a:p>
-            <a:r>
-              <a:t>그리고 그들의 30세션 누적 자산(칩스) 시계열 추이 곡선을 화면에 대조하여 뿌려줍니다.</a:t>
-            </a:r>
-          </a:p>
-          <a:p>
-            <a:r>
-              <a:t>이를 통해 유저는 '내가 베팅 습관을 고치지 않으면 몇 게임 뒤에 파산하여 이탈(Churn)할 확률이 높겠구나' 혹은 '안정적으로 성장하겠구나'를 스스로 시뮬레이션할 수 있습니다."</a:t>
+              <a:t>만약 유저가 돈을 크게 잃고 이탈할 수밖에 없는 Loose-Passive 상태를 설정하면, 화면에는 3인의 유저 자산 그래프가 가파르게 우하향하며 파산하는 모습이 그려집니다. 유저는 이 시뮬레이션을 통해 본인의 잘못된 플레이 전략이 미래 자산에 미칠 충격을 직접 체감하고, 지표를 개선(VPIP 15~22%, AF 2.0~3.5)하여 우상향하는 그래프를 매칭받도록 본인의 전략 의사결정을 수정하게 됩니다."</a:t>
             </a:r>
           </a:p>
           <a:p/>
@@ -1017,7 +1000,7 @@
           </a:p>
           <a:p>
             <a:r>
-              <a:t>- Streamlit(스트림릿): 파이썬 코드를 즉각 멋진 대화형 웹사이트로 변형해 주는 라이브러리.</a:t>
+              <a:t>- 샌드박스: 가상의 공간에서 안전하게 자유로운 모의실험을 해볼 수 있는 환경.</a:t>
             </a:r>
           </a:p>
         </p:txBody>
@@ -1134,11 +1117,6 @@
           <a:p>
             <a:r>
               <a:t>- 성향점수 매칭 (PSM): A/B 테스트에서 두 집단의 조건 불균형을 잡기 위해 수학적으로 조건이 비슷한 짝을 찾아 맞춰주는 기법.</a:t>
-            </a:r>
-          </a:p>
-          <a:p>
-            <a:r>
-              <a:t>- 부트스트랩 (Bootstrap): 표본이 적을 때 데이터를 수만 번 복원 추출하여 가상 분포를 얻는 신뢰성 확보 통계법.</a:t>
             </a:r>
           </a:p>
           <a:p>
@@ -4385,7 +4363,7 @@
               </a:defRPr>
             </a:pPr>
             <a:r>
-              <a:t>01. 프로젝트 배경 및 비즈니스 목적</a:t>
+              <a:t>01. 프로젝트 배경 및 의사결정 목적</a:t>
             </a:r>
           </a:p>
         </p:txBody>
@@ -4469,7 +4447,7 @@
               </a:defRPr>
             </a:pPr>
             <a:r>
-              <a:t>비즈니스 배경 (Business Context)</a:t>
+              <a:t>비즈니스 분석 및 의사결정 목적</a:t>
             </a:r>
           </a:p>
           <a:p>
@@ -4485,7 +4463,7 @@
               </a:defRPr>
             </a:pPr>
             <a:r>
-              <a:t>■ iGaming/포커 플랫폼의 최우선 과제</a:t>
+              <a:t>■ 분석 배경 및 문제 정의</a:t>
             </a:r>
           </a:p>
           <a:p>
@@ -4501,7 +4479,7 @@
               </a:defRPr>
             </a:pPr>
             <a:r>
-              <a:t>  - 고객 리텐션(Retention) 극대화 및 유저 파산/이탈 방어</a:t>
+              <a:t>  - iGaming 서비스의 핵심은 유저 파산 및 이탈(Churn) 방어</a:t>
             </a:r>
           </a:p>
           <a:p>
@@ -4517,7 +4495,7 @@
               </a:defRPr>
             </a:pPr>
             <a:r>
-              <a:t>  - 올바른 플레이 가이드를 제시하지 못할 경우 유저 이탈로 직결</a:t>
+              <a:t>  - 올바른 플레이 가이드 부재로 인한 급격한 유저 이탈 직면</a:t>
             </a:r>
           </a:p>
           <a:p>
@@ -4546,7 +4524,7 @@
               </a:defRPr>
             </a:pPr>
             <a:r>
-              <a:t>■ 데이터 분석의 요구 사항</a:t>
+              <a:t>■ 지표 분석 및 발견점 (Insight)</a:t>
             </a:r>
           </a:p>
           <a:p>
@@ -4562,8 +4540,53 @@
               </a:defRPr>
             </a:pPr>
             <a:r>
-              <a:t>  - 플레이어의 행동 로그에서 플레이 스타일 지표를 수학적으로 도출</a:t>
-            </a:r>
+              <a:t>  - VPIP, PFR, AF 지표 마트 구축 및 다차원 현황 분석</a:t>
+            </a:r>
+          </a:p>
+          <a:p>
+            <a:pPr>
+              <a:spcAft>
+                <a:spcPts val="800"/>
+              </a:spcAft>
+              <a:defRPr sz="1300">
+                <a:solidFill>
+                  <a:srgbClr val="94A3B8"/>
+                </a:solidFill>
+                <a:latin typeface="Malgun Gothic"/>
+              </a:defRPr>
+            </a:pPr>
+            <a:r>
+              <a:t>  - 수동적 진입 유저(Loose-Passive)가 가장 심각한 칩 손실</a:t>
+            </a:r>
+          </a:p>
+          <a:p>
+            <a:pPr>
+              <a:spcAft>
+                <a:spcPts val="800"/>
+              </a:spcAft>
+              <a:defRPr sz="1300">
+                <a:solidFill>
+                  <a:srgbClr val="94A3B8"/>
+                </a:solidFill>
+                <a:latin typeface="Malgun Gothic"/>
+              </a:defRPr>
+            </a:pPr>
+            <a:r>
+              <a:t>    (평균 -16,393 칩스 적자)을 내며 이탈한다는 사실 규명</a:t>
+            </a:r>
+          </a:p>
+          <a:p>
+            <a:pPr>
+              <a:spcAft>
+                <a:spcPts val="800"/>
+              </a:spcAft>
+              <a:defRPr sz="1300">
+                <a:solidFill>
+                  <a:srgbClr val="94A3B8"/>
+                </a:solidFill>
+                <a:latin typeface="Malgun Gothic"/>
+              </a:defRPr>
+            </a:pPr>
           </a:p>
           <a:p>
             <a:pPr>
@@ -4578,7 +4601,7 @@
               </a:defRPr>
             </a:pPr>
             <a:r>
-              <a:t>  - 플레이 성향 지표와 수익성(Chips Won) 간의 통계적 인과관계 증명 필요</a:t>
+              <a:t>■ 데이터 기반 최종 의사결정 (Core Decision)</a:t>
             </a:r>
           </a:p>
           <a:p>
@@ -4594,233 +4617,51 @@
               </a:defRPr>
             </a:pPr>
             <a:r>
-              <a:t>  - 이를 통해 개인 맞춤형 피드백 및 의사결정 보조 시스템의 정당성 확보</a:t>
-            </a:r>
-          </a:p>
-        </p:txBody>
-      </p:sp>
-      <p:sp>
-        <p:nvSpPr>
-          <p:cNvPr id="6" name="Rounded Rectangle 5"/>
-          <p:cNvSpPr/>
+              <a:t>  - 유저 이탈을 막기 위해 단순히 공식을 나열하는 대신,</a:t>
+            </a:r>
+          </a:p>
+          <a:p>
+            <a:pPr>
+              <a:spcAft>
+                <a:spcPts val="800"/>
+              </a:spcAft>
+              <a:defRPr sz="1300" b="1">
+                <a:solidFill>
+                  <a:srgbClr val="FFFFFF"/>
+                </a:solidFill>
+                <a:latin typeface="Malgun Gothic"/>
+              </a:defRPr>
+            </a:pPr>
+            <a:r>
+              <a:t>  - '유저가 본인의 지표를 변경했을 때 미래의 자산 파산 추이를 모의실험해볼 수 있는 실시간 시뮬레이션(Sandbox) 기능을 대시보드 플랫폼에 신설 및 상용 배포하기로 결정'함.</a:t>
+            </a:r>
+          </a:p>
+        </p:txBody>
+      </p:sp>
+      <p:pic>
+        <p:nvPicPr>
+          <p:cNvPr id="6" name="Picture 5" descr="tab1_overview_1781002564252.png"/>
+          <p:cNvPicPr>
+            <a:picLocks noChangeAspect="1"/>
+          </p:cNvPicPr>
           <p:nvPr/>
-        </p:nvSpPr>
+        </p:nvPicPr>
+        <p:blipFill>
+          <a:blip r:embed="rId2"/>
+          <a:stretch>
+            <a:fillRect/>
+          </a:stretch>
+        </p:blipFill>
         <p:spPr>
           <a:xfrm>
             <a:off x="6309360" y="1645920"/>
-            <a:ext cx="5120640" cy="4389120"/>
-          </a:xfrm>
-          <a:prstGeom prst="roundRect">
-            <a:avLst/>
-          </a:prstGeom>
-          <a:solidFill>
-            <a:srgbClr val="1E293B"/>
-          </a:solidFill>
-          <a:ln w="12700">
-            <a:solidFill>
-              <a:srgbClr val="475569"/>
-            </a:solidFill>
-          </a:ln>
-        </p:spPr>
-        <p:style>
-          <a:lnRef idx="1">
-            <a:schemeClr val="accent1"/>
-          </a:lnRef>
-          <a:fillRef idx="3">
-            <a:schemeClr val="accent1"/>
-          </a:fillRef>
-          <a:effectRef idx="2">
-            <a:schemeClr val="accent1"/>
-          </a:effectRef>
-          <a:fontRef idx="minor">
-            <a:schemeClr val="lt1"/>
-          </a:fontRef>
-        </p:style>
-        <p:txBody>
-          <a:bodyPr rtlCol="0" anchor="ctr"/>
-          <a:lstStyle/>
-          <a:p>
-            <a:pPr algn="ctr"/>
-          </a:p>
-        </p:txBody>
-      </p:sp>
-      <p:sp>
-        <p:nvSpPr>
-          <p:cNvPr id="7" name="TextBox 6"/>
-          <p:cNvSpPr txBox="1"/>
-          <p:nvPr/>
-        </p:nvSpPr>
-        <p:spPr>
-          <a:xfrm>
-            <a:off x="6583680" y="1920240"/>
-            <a:ext cx="4572000" cy="3840480"/>
+            <a:ext cx="5120640" cy="3840480"/>
           </a:xfrm>
           <a:prstGeom prst="rect">
             <a:avLst/>
           </a:prstGeom>
-          <a:noFill/>
         </p:spPr>
-        <p:txBody>
-          <a:bodyPr wrap="square" lIns="0" rIns="0" tIns="0" bIns="0">
-            <a:spAutoFit/>
-          </a:bodyPr>
-          <a:lstStyle/>
-          <a:p>
-            <a:pPr>
-              <a:spcAft>
-                <a:spcPts val="1400"/>
-              </a:spcAft>
-              <a:defRPr sz="1800" b="1">
-                <a:solidFill>
-                  <a:srgbClr val="14B8A6"/>
-                </a:solidFill>
-                <a:latin typeface="Malgun Gothic"/>
-              </a:defRPr>
-            </a:pPr>
-            <a:r>
-              <a:t>핵심 분석 및 해결 목적 (Core Objectives)</a:t>
-            </a:r>
-          </a:p>
-          <a:p>
-            <a:pPr>
-              <a:spcAft>
-                <a:spcPts val="800"/>
-              </a:spcAft>
-              <a:defRPr sz="1300">
-                <a:solidFill>
-                  <a:srgbClr val="94A3B8"/>
-                </a:solidFill>
-                <a:latin typeface="Malgun Gothic"/>
-              </a:defRPr>
-            </a:pPr>
-            <a:r>
-              <a:t>■ 1단계: 비정형 데이터의 구조화 및 파이프라인 수립</a:t>
-            </a:r>
-          </a:p>
-          <a:p>
-            <a:pPr>
-              <a:spcAft>
-                <a:spcPts val="800"/>
-              </a:spcAft>
-              <a:defRPr sz="1300">
-                <a:solidFill>
-                  <a:srgbClr val="94A3B8"/>
-                </a:solidFill>
-                <a:latin typeface="Malgun Gothic"/>
-              </a:defRPr>
-            </a:pPr>
-            <a:r>
-              <a:t>  - 비형식적인 텍스트 로그 데이터를 관계형 DB 스키마로 가공 적재</a:t>
-            </a:r>
-          </a:p>
-          <a:p>
-            <a:pPr>
-              <a:spcAft>
-                <a:spcPts val="800"/>
-              </a:spcAft>
-              <a:defRPr sz="1300">
-                <a:solidFill>
-                  <a:srgbClr val="94A3B8"/>
-                </a:solidFill>
-                <a:latin typeface="Malgun Gothic"/>
-              </a:defRPr>
-            </a:pPr>
-          </a:p>
-          <a:p>
-            <a:pPr>
-              <a:spcAft>
-                <a:spcPts val="800"/>
-              </a:spcAft>
-              <a:defRPr sz="1300">
-                <a:solidFill>
-                  <a:srgbClr val="94A3B8"/>
-                </a:solidFill>
-                <a:latin typeface="Malgun Gothic"/>
-              </a:defRPr>
-            </a:pPr>
-            <a:r>
-              <a:t>■ 2단계: 통계 분석 및 머신러닝 모델링</a:t>
-            </a:r>
-          </a:p>
-          <a:p>
-            <a:pPr>
-              <a:spcAft>
-                <a:spcPts val="800"/>
-              </a:spcAft>
-              <a:defRPr sz="1300">
-                <a:solidFill>
-                  <a:srgbClr val="94A3B8"/>
-                </a:solidFill>
-                <a:latin typeface="Malgun Gothic"/>
-              </a:defRPr>
-            </a:pPr>
-            <a:r>
-              <a:t>  - 진입 전략에 따른 수익 차이 T-검정 및 플레이 성향별 군집 정의</a:t>
-            </a:r>
-          </a:p>
-          <a:p>
-            <a:pPr>
-              <a:spcAft>
-                <a:spcPts val="800"/>
-              </a:spcAft>
-              <a:defRPr sz="1300">
-                <a:solidFill>
-                  <a:srgbClr val="94A3B8"/>
-                </a:solidFill>
-                <a:latin typeface="Malgun Gothic"/>
-              </a:defRPr>
-            </a:pPr>
-            <a:r>
-              <a:t>  - 유저 지표 기준 흑자/적자 분류 성능 80% 이상 확보</a:t>
-            </a:r>
-          </a:p>
-          <a:p>
-            <a:pPr>
-              <a:spcAft>
-                <a:spcPts val="800"/>
-              </a:spcAft>
-              <a:defRPr sz="1300">
-                <a:solidFill>
-                  <a:srgbClr val="94A3B8"/>
-                </a:solidFill>
-                <a:latin typeface="Malgun Gothic"/>
-              </a:defRPr>
-            </a:pPr>
-          </a:p>
-          <a:p>
-            <a:pPr>
-              <a:spcAft>
-                <a:spcPts val="800"/>
-              </a:spcAft>
-              <a:defRPr sz="1300">
-                <a:solidFill>
-                  <a:srgbClr val="94A3B8"/>
-                </a:solidFill>
-                <a:latin typeface="Malgun Gothic"/>
-              </a:defRPr>
-            </a:pPr>
-            <a:r>
-              <a:t>■ 3단계: 분석 결과의 플랫폼 서비스화 (Streamlit)</a:t>
-            </a:r>
-          </a:p>
-          <a:p>
-            <a:pPr>
-              <a:spcAft>
-                <a:spcPts val="800"/>
-              </a:spcAft>
-              <a:defRPr sz="1300">
-                <a:solidFill>
-                  <a:srgbClr val="94A3B8"/>
-                </a:solidFill>
-                <a:latin typeface="Malgun Gothic"/>
-              </a:defRPr>
-            </a:pPr>
-            <a:r>
-              <a:t>  - 분석 결과물인 시뮬레이터를 대화형 플랫폼으로 배포하여 유저가 스스로 플레이 전략 변경 시의 미래 자산 추이를 모의실험하도록 유도</a:t>
-            </a:r>
-          </a:p>
-        </p:txBody>
-      </p:sp>
+      </p:pic>
     </p:spTree>
   </p:cSld>
   <p:clrMapOvr>
@@ -4914,7 +4755,7 @@
               </a:defRPr>
             </a:pPr>
             <a:r>
-              <a:t>02. 비정형 로그 정제 및 데이터 파이프라인 구축</a:t>
+              <a:t>02. 활용 데이터 및 ETL 파이프라인 수립</a:t>
             </a:r>
           </a:p>
         </p:txBody>
@@ -4998,7 +4839,7 @@
               </a:defRPr>
             </a:pPr>
             <a:r>
-              <a:t>활용 데이터 스펙 (Data Specification)</a:t>
+              <a:t>비정형 데이터 모델링 및 적재 역할</a:t>
             </a:r>
           </a:p>
           <a:p>
@@ -5014,7 +4855,7 @@
               </a:defRPr>
             </a:pPr>
             <a:r>
-              <a:t>■ 원천 데이터 세트</a:t>
+              <a:t>■ 활용 데이터 (What)</a:t>
             </a:r>
           </a:p>
           <a:p>
@@ -5038,15 +4879,31 @@
               <a:spcAft>
                 <a:spcPts val="800"/>
               </a:spcAft>
-              <a:defRPr sz="1300">
-                <a:solidFill>
-                  <a:srgbClr val="94A3B8"/>
+              <a:defRPr sz="1300" b="1">
+                <a:solidFill>
+                  <a:srgbClr val="FFFFFF"/>
                 </a:solidFill>
                 <a:latin typeface="Malgun Gothic"/>
               </a:defRPr>
             </a:pPr>
             <a:r>
-              <a:t>  - 포커 테이블 내 모든 실시간 이벤트를 시간순으로 기록한 로우 로그</a:t>
+              <a:t>  - 총 7,993개 핸드 (Games), 932명 플레이어 데이터</a:t>
+            </a:r>
+          </a:p>
+          <a:p>
+            <a:pPr>
+              <a:spcAft>
+                <a:spcPts val="800"/>
+              </a:spcAft>
+              <a:defRPr sz="1300" b="1">
+                <a:solidFill>
+                  <a:srgbClr val="FFFFFF"/>
+                </a:solidFill>
+                <a:latin typeface="Malgun Gothic"/>
+              </a:defRPr>
+            </a:pPr>
+            <a:r>
+              <a:t>  - 10만 행 이상의 플레이어별 상세 액션 로그 분석</a:t>
             </a:r>
           </a:p>
           <a:p>
@@ -5075,7 +4932,7 @@
               </a:defRPr>
             </a:pPr>
             <a:r>
-              <a:t>■ 데이터 볼륨</a:t>
+              <a:t>■ 본인의 핵심 설계 역할 (How)</a:t>
             </a:r>
           </a:p>
           <a:p>
@@ -5091,7 +4948,7 @@
               </a:defRPr>
             </a:pPr>
             <a:r>
-              <a:t>  - 총 7,993개 핸드 (Games), 932명 플레이어 데이터</a:t>
+              <a:t>  - 정규표현식(Regex) 파서 설계: 줄글 형태의 원천 텍스트에서 베팅 금액, 플레이어명, 액션 단계를 필터 오차 없이 파싱</a:t>
             </a:r>
           </a:p>
           <a:p>
@@ -5107,7 +4964,7 @@
               </a:defRPr>
             </a:pPr>
             <a:r>
-              <a:t>  - 10만 행 이상의 플레이어별 상세 액션 로그 분석</a:t>
+              <a:t>  - 스타 스키마(Star Schema) 모델링: DW 설계 표준인 Fact(`hands`, `actions`) 및 Dimension(`players`, `tournaments`) 구조 설계</a:t>
             </a:r>
           </a:p>
           <a:p>
@@ -5115,302 +4972,43 @@
               <a:spcAft>
                 <a:spcPts val="800"/>
               </a:spcAft>
-              <a:defRPr sz="1300">
-                <a:solidFill>
-                  <a:srgbClr val="94A3B8"/>
+              <a:defRPr sz="1300" b="1">
+                <a:solidFill>
+                  <a:srgbClr val="FFFFFF"/>
                 </a:solidFill>
                 <a:latin typeface="Malgun Gothic"/>
               </a:defRPr>
             </a:pPr>
             <a:r>
-              <a:t>    (Pre-flop, Flop, Turn, River 단계별 Bet, Call, Raise, Fold)</a:t>
-            </a:r>
-          </a:p>
-          <a:p>
-            <a:pPr>
-              <a:spcAft>
-                <a:spcPts val="800"/>
-              </a:spcAft>
-              <a:defRPr sz="1300">
-                <a:solidFill>
-                  <a:srgbClr val="94A3B8"/>
-                </a:solidFill>
-                <a:latin typeface="Malgun Gothic"/>
-              </a:defRPr>
-            </a:pPr>
-          </a:p>
-          <a:p>
-            <a:pPr>
-              <a:spcAft>
-                <a:spcPts val="800"/>
-              </a:spcAft>
-              <a:defRPr sz="1300">
-                <a:solidFill>
-                  <a:srgbClr val="94A3B8"/>
-                </a:solidFill>
-                <a:latin typeface="Malgun Gothic"/>
-              </a:defRPr>
-            </a:pPr>
-            <a:r>
-              <a:t>■ 핵심 챌린지</a:t>
-            </a:r>
-          </a:p>
-          <a:p>
-            <a:pPr>
-              <a:spcAft>
-                <a:spcPts val="800"/>
-              </a:spcAft>
-              <a:defRPr sz="1300">
-                <a:solidFill>
-                  <a:srgbClr val="94A3B8"/>
-                </a:solidFill>
-                <a:latin typeface="Malgun Gothic"/>
-              </a:defRPr>
-            </a:pPr>
-            <a:r>
-              <a:t>  - 비형식적인 문자열 데이터에서 데이터 일관성을 해치지 않고 플레이어 포지션, 배팅 칩스, 액션 흐름을 누락 없이 파싱하는 프로세스 설계</a:t>
-            </a:r>
-          </a:p>
-        </p:txBody>
-      </p:sp>
-      <p:sp>
-        <p:nvSpPr>
-          <p:cNvPr id="6" name="Rounded Rectangle 5"/>
-          <p:cNvSpPr/>
+              <a:t>  - 이중 DB 호환성: 가벼운 SQLite 파일 DB와 상용 PostgreSQL DB 간에 환경 변수 1개로 적재 및 조회를 전환하는 호환 레이어 구현</a:t>
+            </a:r>
+          </a:p>
+        </p:txBody>
+      </p:sp>
+      <p:pic>
+        <p:nvPicPr>
+          <p:cNvPr id="6" name="Picture 5" descr="tab2_profiling_1781002574421.png"/>
+          <p:cNvPicPr>
+            <a:picLocks noChangeAspect="1"/>
+          </p:cNvPicPr>
           <p:nvPr/>
-        </p:nvSpPr>
+        </p:nvPicPr>
+        <p:blipFill>
+          <a:blip r:embed="rId2"/>
+          <a:stretch>
+            <a:fillRect/>
+          </a:stretch>
+        </p:blipFill>
         <p:spPr>
           <a:xfrm>
             <a:off x="6309360" y="1645920"/>
-            <a:ext cx="5120640" cy="4389120"/>
-          </a:xfrm>
-          <a:prstGeom prst="roundRect">
-            <a:avLst/>
-          </a:prstGeom>
-          <a:solidFill>
-            <a:srgbClr val="1E293B"/>
-          </a:solidFill>
-          <a:ln w="12700">
-            <a:solidFill>
-              <a:srgbClr val="475569"/>
-            </a:solidFill>
-          </a:ln>
-        </p:spPr>
-        <p:style>
-          <a:lnRef idx="1">
-            <a:schemeClr val="accent1"/>
-          </a:lnRef>
-          <a:fillRef idx="3">
-            <a:schemeClr val="accent1"/>
-          </a:fillRef>
-          <a:effectRef idx="2">
-            <a:schemeClr val="accent1"/>
-          </a:effectRef>
-          <a:fontRef idx="minor">
-            <a:schemeClr val="lt1"/>
-          </a:fontRef>
-        </p:style>
-        <p:txBody>
-          <a:bodyPr rtlCol="0" anchor="ctr"/>
-          <a:lstStyle/>
-          <a:p>
-            <a:pPr algn="ctr"/>
-          </a:p>
-        </p:txBody>
-      </p:sp>
-      <p:sp>
-        <p:nvSpPr>
-          <p:cNvPr id="7" name="TextBox 6"/>
-          <p:cNvSpPr txBox="1"/>
-          <p:nvPr/>
-        </p:nvSpPr>
-        <p:spPr>
-          <a:xfrm>
-            <a:off x="6583680" y="1920240"/>
-            <a:ext cx="4572000" cy="3840480"/>
+            <a:ext cx="5120640" cy="3840480"/>
           </a:xfrm>
           <a:prstGeom prst="rect">
             <a:avLst/>
           </a:prstGeom>
-          <a:noFill/>
         </p:spPr>
-        <p:txBody>
-          <a:bodyPr wrap="square" lIns="0" rIns="0" tIns="0" bIns="0">
-            <a:spAutoFit/>
-          </a:bodyPr>
-          <a:lstStyle/>
-          <a:p>
-            <a:pPr>
-              <a:spcAft>
-                <a:spcPts val="1400"/>
-              </a:spcAft>
-              <a:defRPr sz="1800" b="1">
-                <a:solidFill>
-                  <a:srgbClr val="14B8A6"/>
-                </a:solidFill>
-                <a:latin typeface="Malgun Gothic"/>
-              </a:defRPr>
-            </a:pPr>
-            <a:r>
-              <a:t>본인이 수행한 핵심 역할 (Role &amp; Contribution)</a:t>
-            </a:r>
-          </a:p>
-          <a:p>
-            <a:pPr>
-              <a:spcAft>
-                <a:spcPts val="800"/>
-              </a:spcAft>
-              <a:defRPr sz="1300">
-                <a:solidFill>
-                  <a:srgbClr val="94A3B8"/>
-                </a:solidFill>
-                <a:latin typeface="Malgun Gothic"/>
-              </a:defRPr>
-            </a:pPr>
-            <a:r>
-              <a:t>■ 1. Regex 기반 고속 파서 자체 설계</a:t>
-            </a:r>
-          </a:p>
-          <a:p>
-            <a:pPr>
-              <a:spcAft>
-                <a:spcPts val="800"/>
-              </a:spcAft>
-              <a:defRPr sz="1300">
-                <a:solidFill>
-                  <a:srgbClr val="94A3B8"/>
-                </a:solidFill>
-                <a:latin typeface="Malgun Gothic"/>
-              </a:defRPr>
-            </a:pPr>
-            <a:r>
-              <a:t>  - Python 정규표현식(Regex)을 복합 활용하여 비정형 포커 액션 데이터를 시간 단위, 플레이어 단위로 완벽 분리 및 추출 성공</a:t>
-            </a:r>
-          </a:p>
-          <a:p>
-            <a:pPr>
-              <a:spcAft>
-                <a:spcPts val="800"/>
-              </a:spcAft>
-              <a:defRPr sz="1300">
-                <a:solidFill>
-                  <a:srgbClr val="94A3B8"/>
-                </a:solidFill>
-                <a:latin typeface="Malgun Gothic"/>
-              </a:defRPr>
-            </a:pPr>
-          </a:p>
-          <a:p>
-            <a:pPr>
-              <a:spcAft>
-                <a:spcPts val="800"/>
-              </a:spcAft>
-              <a:defRPr sz="1300">
-                <a:solidFill>
-                  <a:srgbClr val="94A3B8"/>
-                </a:solidFill>
-                <a:latin typeface="Malgun Gothic"/>
-              </a:defRPr>
-            </a:pPr>
-            <a:r>
-              <a:t>■ 2. Star Schema 데이터 웨어하우스 모델링</a:t>
-            </a:r>
-          </a:p>
-          <a:p>
-            <a:pPr>
-              <a:spcAft>
-                <a:spcPts val="800"/>
-              </a:spcAft>
-              <a:defRPr sz="1300">
-                <a:solidFill>
-                  <a:srgbClr val="94A3B8"/>
-                </a:solidFill>
-                <a:latin typeface="Malgun Gothic"/>
-              </a:defRPr>
-            </a:pPr>
-            <a:r>
-              <a:t>  - 분석 쿼리 성능과 일관성을 높이기 위해 다차원 스타 스키마 설계</a:t>
-            </a:r>
-          </a:p>
-          <a:p>
-            <a:pPr>
-              <a:spcAft>
-                <a:spcPts val="800"/>
-              </a:spcAft>
-              <a:defRPr sz="1300">
-                <a:solidFill>
-                  <a:srgbClr val="94A3B8"/>
-                </a:solidFill>
-                <a:latin typeface="Malgun Gothic"/>
-              </a:defRPr>
-            </a:pPr>
-            <a:r>
-              <a:t>  - Fact Table: `hands`, `actions` (게임 결과 및 배팅 내역)</a:t>
-            </a:r>
-          </a:p>
-          <a:p>
-            <a:pPr>
-              <a:spcAft>
-                <a:spcPts val="800"/>
-              </a:spcAft>
-              <a:defRPr sz="1300">
-                <a:solidFill>
-                  <a:srgbClr val="94A3B8"/>
-                </a:solidFill>
-                <a:latin typeface="Malgun Gothic"/>
-              </a:defRPr>
-            </a:pPr>
-            <a:r>
-              <a:t>  - Dimension Table: `players`, `tournaments` (유저 및 토너먼트 유형 정보)</a:t>
-            </a:r>
-          </a:p>
-          <a:p>
-            <a:pPr>
-              <a:spcAft>
-                <a:spcPts val="800"/>
-              </a:spcAft>
-              <a:defRPr sz="1300">
-                <a:solidFill>
-                  <a:srgbClr val="94A3B8"/>
-                </a:solidFill>
-                <a:latin typeface="Malgun Gothic"/>
-              </a:defRPr>
-            </a:pPr>
-          </a:p>
-          <a:p>
-            <a:pPr>
-              <a:spcAft>
-                <a:spcPts val="800"/>
-              </a:spcAft>
-              <a:defRPr sz="1300">
-                <a:solidFill>
-                  <a:srgbClr val="94A3B8"/>
-                </a:solidFill>
-                <a:latin typeface="Malgun Gothic"/>
-              </a:defRPr>
-            </a:pPr>
-            <a:r>
-              <a:t>■ 3. DB 마이그레이션 호환성 레이어 구축</a:t>
-            </a:r>
-          </a:p>
-          <a:p>
-            <a:pPr>
-              <a:spcAft>
-                <a:spcPts val="800"/>
-              </a:spcAft>
-              <a:defRPr sz="1300">
-                <a:solidFill>
-                  <a:srgbClr val="94A3B8"/>
-                </a:solidFill>
-                <a:latin typeface="Malgun Gothic"/>
-              </a:defRPr>
-            </a:pPr>
-            <a:r>
-              <a:t>  - SQLite 파일 DB와 PostgreSQL 엔터프라이즈 RDBMS의 접속을 동적 매핑하여 단일 환경 변수 설정으로 ETL 적재 스위칭 가능하도록 설계</a:t>
-            </a:r>
-          </a:p>
-        </p:txBody>
-      </p:sp>
+      </p:pic>
     </p:spTree>
   </p:cSld>
   <p:clrMapOvr>
@@ -5504,729 +5102,7 @@
               </a:defRPr>
             </a:pPr>
             <a:r>
-              <a:t>03. 통계적 가설 검정 및 머신러닝 분석</a:t>
-            </a:r>
-          </a:p>
-        </p:txBody>
-      </p:sp>
-      <p:sp>
-        <p:nvSpPr>
-          <p:cNvPr id="4" name="Rounded Rectangle 3"/>
-          <p:cNvSpPr/>
-          <p:nvPr/>
-        </p:nvSpPr>
-        <p:spPr>
-          <a:xfrm>
-            <a:off x="731520" y="1645920"/>
-            <a:ext cx="3383280" cy="4389120"/>
-          </a:xfrm>
-          <a:prstGeom prst="roundRect">
-            <a:avLst/>
-          </a:prstGeom>
-          <a:solidFill>
-            <a:srgbClr val="1E293B"/>
-          </a:solidFill>
-          <a:ln w="12700">
-            <a:solidFill>
-              <a:srgbClr val="475569"/>
-            </a:solidFill>
-          </a:ln>
-        </p:spPr>
-        <p:style>
-          <a:lnRef idx="1">
-            <a:schemeClr val="accent1"/>
-          </a:lnRef>
-          <a:fillRef idx="3">
-            <a:schemeClr val="accent1"/>
-          </a:fillRef>
-          <a:effectRef idx="2">
-            <a:schemeClr val="accent1"/>
-          </a:effectRef>
-          <a:fontRef idx="minor">
-            <a:schemeClr val="lt1"/>
-          </a:fontRef>
-        </p:style>
-        <p:txBody>
-          <a:bodyPr rtlCol="0" anchor="ctr"/>
-          <a:lstStyle/>
-          <a:p>
-            <a:pPr algn="ctr"/>
-          </a:p>
-        </p:txBody>
-      </p:sp>
-      <p:sp>
-        <p:nvSpPr>
-          <p:cNvPr id="5" name="TextBox 4"/>
-          <p:cNvSpPr txBox="1"/>
-          <p:nvPr/>
-        </p:nvSpPr>
-        <p:spPr>
-          <a:xfrm>
-            <a:off x="1005840" y="1920240"/>
-            <a:ext cx="2834640" cy="3840480"/>
-          </a:xfrm>
-          <a:prstGeom prst="rect">
-            <a:avLst/>
-          </a:prstGeom>
-          <a:noFill/>
-        </p:spPr>
-        <p:txBody>
-          <a:bodyPr wrap="square" lIns="0" rIns="0" tIns="0" bIns="0">
-            <a:spAutoFit/>
-          </a:bodyPr>
-          <a:lstStyle/>
-          <a:p>
-            <a:pPr>
-              <a:spcAft>
-                <a:spcPts val="1400"/>
-              </a:spcAft>
-              <a:defRPr sz="1800" b="1">
-                <a:solidFill>
-                  <a:srgbClr val="14B8A6"/>
-                </a:solidFill>
-                <a:latin typeface="Malgun Gothic"/>
-              </a:defRPr>
-            </a:pPr>
-            <a:r>
-              <a:t>도메인 KPI 계산</a:t>
-            </a:r>
-          </a:p>
-          <a:p>
-            <a:pPr>
-              <a:spcAft>
-                <a:spcPts val="800"/>
-              </a:spcAft>
-              <a:defRPr sz="1300">
-                <a:solidFill>
-                  <a:srgbClr val="94A3B8"/>
-                </a:solidFill>
-                <a:latin typeface="Malgun Gothic"/>
-              </a:defRPr>
-            </a:pPr>
-            <a:r>
-              <a:t>■ 핵심 지표 SQL 마트 구축</a:t>
-            </a:r>
-          </a:p>
-          <a:p>
-            <a:pPr>
-              <a:spcAft>
-                <a:spcPts val="800"/>
-              </a:spcAft>
-              <a:defRPr sz="1300">
-                <a:solidFill>
-                  <a:srgbClr val="94A3B8"/>
-                </a:solidFill>
-                <a:latin typeface="Malgun Gothic"/>
-              </a:defRPr>
-            </a:pPr>
-            <a:r>
-              <a:t>  - VPIP(자발적 참여율)</a:t>
-            </a:r>
-          </a:p>
-          <a:p>
-            <a:pPr>
-              <a:spcAft>
-                <a:spcPts val="800"/>
-              </a:spcAft>
-              <a:defRPr sz="1300">
-                <a:solidFill>
-                  <a:srgbClr val="94A3B8"/>
-                </a:solidFill>
-                <a:latin typeface="Malgun Gothic"/>
-              </a:defRPr>
-            </a:pPr>
-            <a:r>
-              <a:t>  - PFR(선제공격률)</a:t>
-            </a:r>
-          </a:p>
-          <a:p>
-            <a:pPr>
-              <a:spcAft>
-                <a:spcPts val="800"/>
-              </a:spcAft>
-              <a:defRPr sz="1300">
-                <a:solidFill>
-                  <a:srgbClr val="94A3B8"/>
-                </a:solidFill>
-                <a:latin typeface="Malgun Gothic"/>
-              </a:defRPr>
-            </a:pPr>
-            <a:r>
-              <a:t>  - AF(포스트플랍 공격성)</a:t>
-            </a:r>
-          </a:p>
-          <a:p>
-            <a:pPr>
-              <a:spcAft>
-                <a:spcPts val="800"/>
-              </a:spcAft>
-              <a:defRPr sz="1300">
-                <a:solidFill>
-                  <a:srgbClr val="94A3B8"/>
-                </a:solidFill>
-                <a:latin typeface="Malgun Gothic"/>
-              </a:defRPr>
-            </a:pPr>
-            <a:r>
-              <a:t>  - Win Rate(최종 승률)</a:t>
-            </a:r>
-          </a:p>
-          <a:p>
-            <a:pPr>
-              <a:spcAft>
-                <a:spcPts val="800"/>
-              </a:spcAft>
-              <a:defRPr sz="1300">
-                <a:solidFill>
-                  <a:srgbClr val="94A3B8"/>
-                </a:solidFill>
-                <a:latin typeface="Malgun Gothic"/>
-              </a:defRPr>
-            </a:pPr>
-          </a:p>
-          <a:p>
-            <a:pPr>
-              <a:spcAft>
-                <a:spcPts val="800"/>
-              </a:spcAft>
-              <a:defRPr sz="1300">
-                <a:solidFill>
-                  <a:srgbClr val="94A3B8"/>
-                </a:solidFill>
-                <a:latin typeface="Malgun Gothic"/>
-              </a:defRPr>
-            </a:pPr>
-            <a:r>
-              <a:t>■ 윈도우/집계 함수 최적화</a:t>
-            </a:r>
-          </a:p>
-          <a:p>
-            <a:pPr>
-              <a:spcAft>
-                <a:spcPts val="800"/>
-              </a:spcAft>
-              <a:defRPr sz="1300">
-                <a:solidFill>
-                  <a:srgbClr val="94A3B8"/>
-                </a:solidFill>
-                <a:latin typeface="Malgun Gothic"/>
-              </a:defRPr>
-            </a:pPr>
-            <a:r>
-              <a:t>  - 932명 유저에 대한 지표를 중첩 스캔 없이 고속 산출하는 SQL 로직 구축</a:t>
-            </a:r>
-          </a:p>
-        </p:txBody>
-      </p:sp>
-      <p:sp>
-        <p:nvSpPr>
-          <p:cNvPr id="6" name="Rounded Rectangle 5"/>
-          <p:cNvSpPr/>
-          <p:nvPr/>
-        </p:nvSpPr>
-        <p:spPr>
-          <a:xfrm>
-            <a:off x="4389120" y="1645920"/>
-            <a:ext cx="3383280" cy="4389120"/>
-          </a:xfrm>
-          <a:prstGeom prst="roundRect">
-            <a:avLst/>
-          </a:prstGeom>
-          <a:solidFill>
-            <a:srgbClr val="1E293B"/>
-          </a:solidFill>
-          <a:ln w="12700">
-            <a:solidFill>
-              <a:srgbClr val="475569"/>
-            </a:solidFill>
-          </a:ln>
-        </p:spPr>
-        <p:style>
-          <a:lnRef idx="1">
-            <a:schemeClr val="accent1"/>
-          </a:lnRef>
-          <a:fillRef idx="3">
-            <a:schemeClr val="accent1"/>
-          </a:fillRef>
-          <a:effectRef idx="2">
-            <a:schemeClr val="accent1"/>
-          </a:effectRef>
-          <a:fontRef idx="minor">
-            <a:schemeClr val="lt1"/>
-          </a:fontRef>
-        </p:style>
-        <p:txBody>
-          <a:bodyPr rtlCol="0" anchor="ctr"/>
-          <a:lstStyle/>
-          <a:p>
-            <a:pPr algn="ctr"/>
-          </a:p>
-        </p:txBody>
-      </p:sp>
-      <p:sp>
-        <p:nvSpPr>
-          <p:cNvPr id="7" name="TextBox 6"/>
-          <p:cNvSpPr txBox="1"/>
-          <p:nvPr/>
-        </p:nvSpPr>
-        <p:spPr>
-          <a:xfrm>
-            <a:off x="4663440" y="1920240"/>
-            <a:ext cx="2834640" cy="3840480"/>
-          </a:xfrm>
-          <a:prstGeom prst="rect">
-            <a:avLst/>
-          </a:prstGeom>
-          <a:noFill/>
-        </p:spPr>
-        <p:txBody>
-          <a:bodyPr wrap="square" lIns="0" rIns="0" tIns="0" bIns="0">
-            <a:spAutoFit/>
-          </a:bodyPr>
-          <a:lstStyle/>
-          <a:p>
-            <a:pPr>
-              <a:spcAft>
-                <a:spcPts val="1400"/>
-              </a:spcAft>
-              <a:defRPr sz="1800" b="1">
-                <a:solidFill>
-                  <a:srgbClr val="14B8A6"/>
-                </a:solidFill>
-                <a:latin typeface="Malgun Gothic"/>
-              </a:defRPr>
-            </a:pPr>
-            <a:r>
-              <a:t>통계적 가설 검정 (A/B Test)</a:t>
-            </a:r>
-          </a:p>
-          <a:p>
-            <a:pPr>
-              <a:spcAft>
-                <a:spcPts val="800"/>
-              </a:spcAft>
-              <a:defRPr sz="1300">
-                <a:solidFill>
-                  <a:srgbClr val="94A3B8"/>
-                </a:solidFill>
-                <a:latin typeface="Malgun Gothic"/>
-              </a:defRPr>
-            </a:pPr>
-            <a:r>
-              <a:t>■ 가설 정의</a:t>
-            </a:r>
-          </a:p>
-          <a:p>
-            <a:pPr>
-              <a:spcAft>
-                <a:spcPts val="800"/>
-              </a:spcAft>
-              <a:defRPr sz="1300">
-                <a:solidFill>
-                  <a:srgbClr val="94A3B8"/>
-                </a:solidFill>
-                <a:latin typeface="Malgun Gothic"/>
-              </a:defRPr>
-            </a:pPr>
-            <a:r>
-              <a:t>  - 프리미엄 카드 보유 시 선공(A)과 단순 콜(B) 진입의 칩 획득량 차이 검증</a:t>
-            </a:r>
-          </a:p>
-          <a:p>
-            <a:pPr>
-              <a:spcAft>
-                <a:spcPts val="800"/>
-              </a:spcAft>
-              <a:defRPr sz="1300">
-                <a:solidFill>
-                  <a:srgbClr val="94A3B8"/>
-                </a:solidFill>
-                <a:latin typeface="Malgun Gothic"/>
-              </a:defRPr>
-            </a:pPr>
-          </a:p>
-          <a:p>
-            <a:pPr>
-              <a:spcAft>
-                <a:spcPts val="800"/>
-              </a:spcAft>
-              <a:defRPr sz="1300" b="1">
-                <a:solidFill>
-                  <a:srgbClr val="3B82F6"/>
-                </a:solidFill>
-                <a:latin typeface="Malgun Gothic"/>
-              </a:defRPr>
-            </a:pPr>
-            <a:r>
-              <a:t>■ 분석 기법</a:t>
-            </a:r>
-          </a:p>
-          <a:p>
-            <a:pPr>
-              <a:spcAft>
-                <a:spcPts val="800"/>
-              </a:spcAft>
-              <a:defRPr sz="1300">
-                <a:solidFill>
-                  <a:srgbClr val="94A3B8"/>
-                </a:solidFill>
-                <a:latin typeface="Malgun Gothic"/>
-              </a:defRPr>
-            </a:pPr>
-            <a:r>
-              <a:t>  - 독립표본 T-검정 수행</a:t>
-            </a:r>
-          </a:p>
-          <a:p>
-            <a:pPr>
-              <a:spcAft>
-                <a:spcPts val="800"/>
-              </a:spcAft>
-              <a:defRPr sz="1300">
-                <a:solidFill>
-                  <a:srgbClr val="94A3B8"/>
-                </a:solidFill>
-                <a:latin typeface="Malgun Gothic"/>
-              </a:defRPr>
-            </a:pPr>
-          </a:p>
-          <a:p>
-            <a:pPr>
-              <a:spcAft>
-                <a:spcPts val="800"/>
-              </a:spcAft>
-              <a:defRPr sz="1300">
-                <a:solidFill>
-                  <a:srgbClr val="94A3B8"/>
-                </a:solidFill>
-                <a:latin typeface="Malgun Gothic"/>
-              </a:defRPr>
-            </a:pPr>
-            <a:r>
-              <a:t>■ 검정 결과 및 진단</a:t>
-            </a:r>
-          </a:p>
-          <a:p>
-            <a:pPr>
-              <a:spcAft>
-                <a:spcPts val="800"/>
-              </a:spcAft>
-              <a:defRPr sz="1300" b="1">
-                <a:solidFill>
-                  <a:srgbClr val="FFFFFF"/>
-                </a:solidFill>
-                <a:latin typeface="Malgun Gothic"/>
-              </a:defRPr>
-            </a:pPr>
-            <a:r>
-              <a:t>  - p-value = 0.6372로 가설 기각</a:t>
-            </a:r>
-          </a:p>
-          <a:p>
-            <a:pPr>
-              <a:spcAft>
-                <a:spcPts val="800"/>
-              </a:spcAft>
-              <a:defRPr sz="1300">
-                <a:solidFill>
-                  <a:srgbClr val="94A3B8"/>
-                </a:solidFill>
-                <a:latin typeface="Malgun Gothic"/>
-              </a:defRPr>
-            </a:pPr>
-            <a:r>
-              <a:t>  - 귀무가설 수용 원인 규명: 수동적 콜 진입 집합(대조군)의 모수가 극소수여서 통계적 검정력이 부족했음을 정밀 진단함</a:t>
-            </a:r>
-          </a:p>
-        </p:txBody>
-      </p:sp>
-      <p:sp>
-        <p:nvSpPr>
-          <p:cNvPr id="8" name="Rounded Rectangle 7"/>
-          <p:cNvSpPr/>
-          <p:nvPr/>
-        </p:nvSpPr>
-        <p:spPr>
-          <a:xfrm>
-            <a:off x="8046720" y="1645920"/>
-            <a:ext cx="3383280" cy="4389120"/>
-          </a:xfrm>
-          <a:prstGeom prst="roundRect">
-            <a:avLst/>
-          </a:prstGeom>
-          <a:solidFill>
-            <a:srgbClr val="1E293B"/>
-          </a:solidFill>
-          <a:ln w="12700">
-            <a:solidFill>
-              <a:srgbClr val="475569"/>
-            </a:solidFill>
-          </a:ln>
-        </p:spPr>
-        <p:style>
-          <a:lnRef idx="1">
-            <a:schemeClr val="accent1"/>
-          </a:lnRef>
-          <a:fillRef idx="3">
-            <a:schemeClr val="accent1"/>
-          </a:fillRef>
-          <a:effectRef idx="2">
-            <a:schemeClr val="accent1"/>
-          </a:effectRef>
-          <a:fontRef idx="minor">
-            <a:schemeClr val="lt1"/>
-          </a:fontRef>
-        </p:style>
-        <p:txBody>
-          <a:bodyPr rtlCol="0" anchor="ctr"/>
-          <a:lstStyle/>
-          <a:p>
-            <a:pPr algn="ctr"/>
-          </a:p>
-        </p:txBody>
-      </p:sp>
-      <p:sp>
-        <p:nvSpPr>
-          <p:cNvPr id="9" name="TextBox 8"/>
-          <p:cNvSpPr txBox="1"/>
-          <p:nvPr/>
-        </p:nvSpPr>
-        <p:spPr>
-          <a:xfrm>
-            <a:off x="8321040" y="1920240"/>
-            <a:ext cx="2834640" cy="3840480"/>
-          </a:xfrm>
-          <a:prstGeom prst="rect">
-            <a:avLst/>
-          </a:prstGeom>
-          <a:noFill/>
-        </p:spPr>
-        <p:txBody>
-          <a:bodyPr wrap="square" lIns="0" rIns="0" tIns="0" bIns="0">
-            <a:spAutoFit/>
-          </a:bodyPr>
-          <a:lstStyle/>
-          <a:p>
-            <a:pPr>
-              <a:spcAft>
-                <a:spcPts val="1400"/>
-              </a:spcAft>
-              <a:defRPr sz="1800" b="1">
-                <a:solidFill>
-                  <a:srgbClr val="14B8A6"/>
-                </a:solidFill>
-                <a:latin typeface="Malgun Gothic"/>
-              </a:defRPr>
-            </a:pPr>
-            <a:r>
-              <a:t>머신러닝 모델링 (ML)</a:t>
-            </a:r>
-          </a:p>
-          <a:p>
-            <a:pPr>
-              <a:spcAft>
-                <a:spcPts val="800"/>
-              </a:spcAft>
-              <a:defRPr sz="1300">
-                <a:solidFill>
-                  <a:srgbClr val="94A3B8"/>
-                </a:solidFill>
-                <a:latin typeface="Malgun Gothic"/>
-              </a:defRPr>
-            </a:pPr>
-            <a:r>
-              <a:t>■ K-Means 군집 분석</a:t>
-            </a:r>
-          </a:p>
-          <a:p>
-            <a:pPr>
-              <a:spcAft>
-                <a:spcPts val="800"/>
-              </a:spcAft>
-              <a:defRPr sz="1300">
-                <a:solidFill>
-                  <a:srgbClr val="94A3B8"/>
-                </a:solidFill>
-                <a:latin typeface="Malgun Gothic"/>
-              </a:defRPr>
-            </a:pPr>
-            <a:r>
-              <a:t>  - VPIP, PFR 지표를 표준화하여 엘보우 기법 적용</a:t>
-            </a:r>
-          </a:p>
-          <a:p>
-            <a:pPr>
-              <a:spcAft>
-                <a:spcPts val="800"/>
-              </a:spcAft>
-              <a:defRPr sz="1300" b="1">
-                <a:solidFill>
-                  <a:srgbClr val="FFFFFF"/>
-                </a:solidFill>
-                <a:latin typeface="Malgun Gothic"/>
-              </a:defRPr>
-            </a:pPr>
-            <a:r>
-              <a:t>  - 유저들을 4대 플레이 성향 코호트군으로 명확히 군집화</a:t>
-            </a:r>
-          </a:p>
-          <a:p>
-            <a:pPr>
-              <a:spcAft>
-                <a:spcPts val="800"/>
-              </a:spcAft>
-              <a:defRPr sz="1300">
-                <a:solidFill>
-                  <a:srgbClr val="94A3B8"/>
-                </a:solidFill>
-                <a:latin typeface="Malgun Gothic"/>
-              </a:defRPr>
-            </a:pPr>
-          </a:p>
-          <a:p>
-            <a:pPr>
-              <a:spcAft>
-                <a:spcPts val="800"/>
-              </a:spcAft>
-              <a:defRPr sz="1300">
-                <a:solidFill>
-                  <a:srgbClr val="94A3B8"/>
-                </a:solidFill>
-                <a:latin typeface="Malgun Gothic"/>
-              </a:defRPr>
-            </a:pPr>
-            <a:r>
-              <a:t>■ Random Forest 예측 모델</a:t>
-            </a:r>
-          </a:p>
-          <a:p>
-            <a:pPr>
-              <a:spcAft>
-                <a:spcPts val="800"/>
-              </a:spcAft>
-              <a:defRPr sz="1300">
-                <a:solidFill>
-                  <a:srgbClr val="94A3B8"/>
-                </a:solidFill>
-                <a:latin typeface="Malgun Gothic"/>
-              </a:defRPr>
-            </a:pPr>
-            <a:r>
-              <a:t>  - KPI 피처 기반 유저 흑자 여부 예측 Classifier 학습</a:t>
-            </a:r>
-          </a:p>
-          <a:p>
-            <a:pPr>
-              <a:spcAft>
-                <a:spcPts val="800"/>
-              </a:spcAft>
-              <a:defRPr sz="1300" b="1">
-                <a:solidFill>
-                  <a:srgbClr val="FFFFFF"/>
-                </a:solidFill>
-                <a:latin typeface="Malgun Gothic"/>
-              </a:defRPr>
-            </a:pPr>
-            <a:r>
-              <a:t>  - 모델 성능: Accuracy 84%, ROC-AUC 0.91 달성</a:t>
-            </a:r>
-          </a:p>
-        </p:txBody>
-      </p:sp>
-    </p:spTree>
-  </p:cSld>
-  <p:clrMapOvr>
-    <a:masterClrMapping/>
-  </p:clrMapOvr>
-</p:sld>
-</file>
-
-<file path=ppt/slides/slide5.xml><?xml version="1.0" encoding="utf-8"?>
-<p:sld xmlns:a="http://schemas.openxmlformats.org/drawingml/2006/main" xmlns:p="http://schemas.openxmlformats.org/presentationml/2006/main" xmlns:r="http://schemas.openxmlformats.org/officeDocument/2006/relationships">
-  <p:cSld>
-    <p:bg>
-      <p:bgPr>
-        <a:solidFill>
-          <a:srgbClr val="0F172A"/>
-        </a:solidFill>
-        <a:effectLst/>
-      </p:bgPr>
-    </p:bg>
-    <p:spTree>
-      <p:nvGrpSpPr>
-        <p:cNvPr id="1" name=""/>
-        <p:cNvGrpSpPr/>
-        <p:nvPr/>
-      </p:nvGrpSpPr>
-      <p:grpSpPr/>
-      <p:sp>
-        <p:nvSpPr>
-          <p:cNvPr id="2" name="TextBox 1"/>
-          <p:cNvSpPr txBox="1"/>
-          <p:nvPr/>
-        </p:nvSpPr>
-        <p:spPr>
-          <a:xfrm>
-            <a:off x="731520" y="365760"/>
-            <a:ext cx="10698480" cy="274320"/>
-          </a:xfrm>
-          <a:prstGeom prst="rect">
-            <a:avLst/>
-          </a:prstGeom>
-          <a:noFill/>
-        </p:spPr>
-        <p:txBody>
-          <a:bodyPr wrap="square" lIns="0" rIns="0" tIns="0" bIns="0">
-            <a:spAutoFit/>
-          </a:bodyPr>
-          <a:lstStyle/>
-          <a:p>
-            <a:pPr>
-              <a:defRPr sz="1000" b="1">
-                <a:solidFill>
-                  <a:srgbClr val="14B8A6"/>
-                </a:solidFill>
-                <a:latin typeface="Arial"/>
-              </a:defRPr>
-            </a:pPr>
-            <a:r>
-              <a:t>PLATFORM SERVICE &amp; SIMULATOR</a:t>
-            </a:r>
-          </a:p>
-        </p:txBody>
-      </p:sp>
-      <p:sp>
-        <p:nvSpPr>
-          <p:cNvPr id="3" name="TextBox 2"/>
-          <p:cNvSpPr txBox="1"/>
-          <p:nvPr/>
-        </p:nvSpPr>
-        <p:spPr>
-          <a:xfrm>
-            <a:off x="731520" y="640080"/>
-            <a:ext cx="10698480" cy="731520"/>
-          </a:xfrm>
-          <a:prstGeom prst="rect">
-            <a:avLst/>
-          </a:prstGeom>
-          <a:noFill/>
-        </p:spPr>
-        <p:txBody>
-          <a:bodyPr wrap="square" lIns="0" rIns="0" tIns="0" bIns="0">
-            <a:spAutoFit/>
-          </a:bodyPr>
-          <a:lstStyle/>
-          <a:p>
-            <a:pPr>
-              <a:defRPr sz="2800" b="1">
-                <a:solidFill>
-                  <a:srgbClr val="FFFFFF"/>
-                </a:solidFill>
-                <a:latin typeface="Malgun Gothic"/>
-              </a:defRPr>
-            </a:pPr>
-            <a:r>
-              <a:t>04. 분석 결과의 서비스화: Streamlit 시뮬레이터</a:t>
+              <a:t>03. 통계적 가설 검정 및 의사결정 프로세스</a:t>
             </a:r>
           </a:p>
         </p:txBody>
@@ -6310,7 +5186,7 @@
               </a:defRPr>
             </a:pPr>
             <a:r>
-              <a:t>플랫폼 아키텍처 및 대시보드 구축</a:t>
+              <a:t>통계 기반 가설 검정 및 성향 예측 모델</a:t>
             </a:r>
           </a:p>
           <a:p>
@@ -6326,7 +5202,7 @@
               </a:defRPr>
             </a:pPr>
             <a:r>
-              <a:t>■ Tableau 스타일 다차원 글로벌 필터</a:t>
+              <a:t>■ 가설 설정 및 A/B 테스트 검정</a:t>
             </a:r>
           </a:p>
           <a:p>
@@ -6342,7 +5218,7 @@
               </a:defRPr>
             </a:pPr>
             <a:r>
-              <a:t>  - 사이드바에서 토너먼트 종류, BB 슬라이더, 플레이어 포지션을 조절하면 실시간으로 연동된 SQL 쿼리가 파라미터 바인딩을 통해 전체 분석 차트를 즉시 동적 렌더링</a:t>
+              <a:t>  - 가설: 프리미엄 패를 쥐었을 때 선공(A)으로 진입한 집단이 단순 콜(B)로만 진입한 집단보다 수익이 유의미하게 높을 것이다.</a:t>
             </a:r>
           </a:p>
           <a:p>
@@ -6357,6 +5233,9 @@
                 <a:latin typeface="Malgun Gothic"/>
               </a:defRPr>
             </a:pPr>
+            <a:r>
+              <a:t>  - 독립표본 T-검정 수행 -&gt; p-value = 0.6372로 가설 기각.</a:t>
+            </a:r>
           </a:p>
           <a:p>
             <a:pPr>
@@ -6370,8 +5249,21 @@
                 <a:latin typeface="Malgun Gothic"/>
               </a:defRPr>
             </a:pPr>
-            <a:r>
-              <a:t>■ 오픈 웹 상용화 배포</a:t>
+          </a:p>
+          <a:p>
+            <a:pPr>
+              <a:spcAft>
+                <a:spcPts val="800"/>
+              </a:spcAft>
+              <a:defRPr sz="1300" b="1">
+                <a:solidFill>
+                  <a:srgbClr val="FFFFFF"/>
+                </a:solidFill>
+                <a:latin typeface="Malgun Gothic"/>
+              </a:defRPr>
+            </a:pPr>
+            <a:r>
+              <a:t>■ 데이터 분석 기반의 프로세스 의사결정</a:t>
             </a:r>
           </a:p>
           <a:p>
@@ -6387,7 +5279,23 @@
               </a:defRPr>
             </a:pPr>
             <a:r>
-              <a:t>  - Streamlit Cloud 서비스를 이용해 외부에서도 포트폴리오를 조회하고 검증할 수 있도록 완전 공개 배포 완료</a:t>
+              <a:t>  - 분석 결과 기각되었으나 단순히 기각으로 결론짓지 않고,</a:t>
+            </a:r>
+          </a:p>
+          <a:p>
+            <a:pPr>
+              <a:spcAft>
+                <a:spcPts val="800"/>
+              </a:spcAft>
+              <a:defRPr sz="1300" b="1">
+                <a:solidFill>
+                  <a:srgbClr val="FFFFFF"/>
+                </a:solidFill>
+                <a:latin typeface="Malgun Gothic"/>
+              </a:defRPr>
+            </a:pPr>
+            <a:r>
+              <a:t>  - '대조군인 콜 진입 집합의 표본 크기가 극히 적어 통계적 검정력이 부족했음을 정밀 진단하여, 유저에게 왜곡된 팩트를 가이드하는 대신 표본 보완책(성향점수 매칭, 부트스트랩)을 분석 엔진에 즉각 주입하기 전까지 비즈니스 판단을 유보하고 분석 방식을 보완하는 결정을 내림'.</a:t>
             </a:r>
           </a:p>
           <a:p>
@@ -6402,93 +5310,6 @@
                 <a:latin typeface="Malgun Gothic"/>
               </a:defRPr>
             </a:pPr>
-            <a:r>
-              <a:t>  - 반응형 CSS 및 다국어(한국어/영어) 전환 라우팅을 구축하여 글로벌 유저 대응 역량 확보</a:t>
-            </a:r>
-          </a:p>
-        </p:txBody>
-      </p:sp>
-      <p:sp>
-        <p:nvSpPr>
-          <p:cNvPr id="6" name="Rounded Rectangle 5"/>
-          <p:cNvSpPr/>
-          <p:nvPr/>
-        </p:nvSpPr>
-        <p:spPr>
-          <a:xfrm>
-            <a:off x="6309360" y="1645920"/>
-            <a:ext cx="5120640" cy="4389120"/>
-          </a:xfrm>
-          <a:prstGeom prst="roundRect">
-            <a:avLst/>
-          </a:prstGeom>
-          <a:solidFill>
-            <a:srgbClr val="1E293B"/>
-          </a:solidFill>
-          <a:ln w="12700">
-            <a:solidFill>
-              <a:srgbClr val="475569"/>
-            </a:solidFill>
-          </a:ln>
-        </p:spPr>
-        <p:style>
-          <a:lnRef idx="1">
-            <a:schemeClr val="accent1"/>
-          </a:lnRef>
-          <a:fillRef idx="3">
-            <a:schemeClr val="accent1"/>
-          </a:fillRef>
-          <a:effectRef idx="2">
-            <a:schemeClr val="accent1"/>
-          </a:effectRef>
-          <a:fontRef idx="minor">
-            <a:schemeClr val="lt1"/>
-          </a:fontRef>
-        </p:style>
-        <p:txBody>
-          <a:bodyPr rtlCol="0" anchor="ctr"/>
-          <a:lstStyle/>
-          <a:p>
-            <a:pPr algn="ctr"/>
-          </a:p>
-        </p:txBody>
-      </p:sp>
-      <p:sp>
-        <p:nvSpPr>
-          <p:cNvPr id="7" name="TextBox 6"/>
-          <p:cNvSpPr txBox="1"/>
-          <p:nvPr/>
-        </p:nvSpPr>
-        <p:spPr>
-          <a:xfrm>
-            <a:off x="6583680" y="1920240"/>
-            <a:ext cx="4572000" cy="3840480"/>
-          </a:xfrm>
-          <a:prstGeom prst="rect">
-            <a:avLst/>
-          </a:prstGeom>
-          <a:noFill/>
-        </p:spPr>
-        <p:txBody>
-          <a:bodyPr wrap="square" lIns="0" rIns="0" tIns="0" bIns="0">
-            <a:spAutoFit/>
-          </a:bodyPr>
-          <a:lstStyle/>
-          <a:p>
-            <a:pPr>
-              <a:spcAft>
-                <a:spcPts val="1400"/>
-              </a:spcAft>
-              <a:defRPr sz="1800" b="1">
-                <a:solidFill>
-                  <a:srgbClr val="14B8A6"/>
-                </a:solidFill>
-                <a:latin typeface="Malgun Gothic"/>
-              </a:defRPr>
-            </a:pPr>
-            <a:r>
-              <a:t>플레이 스타일 시뮬레이션 기능</a:t>
-            </a:r>
           </a:p>
           <a:p>
             <a:pPr>
@@ -6503,7 +5324,7 @@
               </a:defRPr>
             </a:pPr>
             <a:r>
-              <a:t>■ 1. 실시간 ETL 적재 시뮬레이션 데모</a:t>
+              <a:t>■ 군집화 및 예측 모델</a:t>
             </a:r>
           </a:p>
           <a:p>
@@ -6519,7 +5340,7 @@
               </a:defRPr>
             </a:pPr>
             <a:r>
-              <a:t>  - 유저가 로그 업로드 시 파일 파싱과 DB 적재 상황을 진행바로 시각화하며 Hero의 수익 곡선 실시간 렌더링</a:t>
+              <a:t>  - K-Means 알고리즘으로 유저 4대 성향 코호트 자동 분류</a:t>
             </a:r>
           </a:p>
           <a:p>
@@ -6534,57 +5355,36 @@
                 <a:latin typeface="Malgun Gothic"/>
               </a:defRPr>
             </a:pPr>
-          </a:p>
-          <a:p>
-            <a:pPr>
-              <a:spcAft>
-                <a:spcPts val="800"/>
-              </a:spcAft>
-              <a:defRPr sz="1300">
-                <a:solidFill>
-                  <a:srgbClr val="94A3B8"/>
-                </a:solidFill>
-                <a:latin typeface="Malgun Gothic"/>
-              </a:defRPr>
-            </a:pPr>
-            <a:r>
-              <a:t>■ 2. 플레이 스타일 샌드박스 플레이그라운드</a:t>
-            </a:r>
-          </a:p>
-          <a:p>
-            <a:pPr>
-              <a:spcAft>
-                <a:spcPts val="800"/>
-              </a:spcAft>
-              <a:defRPr sz="1300">
-                <a:solidFill>
-                  <a:srgbClr val="94A3B8"/>
-                </a:solidFill>
-                <a:latin typeface="Malgun Gothic"/>
-              </a:defRPr>
-            </a:pPr>
-            <a:r>
-              <a:t>  - 유저가 VPIP, PFR, AF 슬라이더를 조정하여 플레이 패턴 설정 시 군집 성향 판정</a:t>
-            </a:r>
-          </a:p>
-          <a:p>
-            <a:pPr>
-              <a:spcAft>
-                <a:spcPts val="800"/>
-              </a:spcAft>
-              <a:defRPr sz="1300" b="1">
-                <a:solidFill>
-                  <a:srgbClr val="FFFFFF"/>
-                </a:solidFill>
-                <a:latin typeface="Malgun Gothic"/>
-              </a:defRPr>
-            </a:pPr>
-            <a:r>
-              <a:t>  - DB 내 가장 유사한 실제 유저 3명을 매칭하고 이들의 30세션 누적 자산 추이 시계열 그래프를 대조하여, '지표 개선 시 자산 파산(이탈) 확률 방어 여부'를 모의 실험 가능하게 구현</a:t>
-            </a:r>
-          </a:p>
-        </p:txBody>
-      </p:sp>
+            <a:r>
+              <a:t>  - Random Forest를 연동해 유저 지표 기반 흑자 예측 (Accuracy 84%)</a:t>
+            </a:r>
+          </a:p>
+        </p:txBody>
+      </p:sp>
+      <p:pic>
+        <p:nvPicPr>
+          <p:cNvPr id="6" name="Picture 5" descr="tab4_ab_test_1781002593463.png"/>
+          <p:cNvPicPr>
+            <a:picLocks noChangeAspect="1"/>
+          </p:cNvPicPr>
+          <p:nvPr/>
+        </p:nvPicPr>
+        <p:blipFill>
+          <a:blip r:embed="rId2"/>
+          <a:stretch>
+            <a:fillRect/>
+          </a:stretch>
+        </p:blipFill>
+        <p:spPr>
+          <a:xfrm>
+            <a:off x="6309360" y="1645920"/>
+            <a:ext cx="5120640" cy="3840480"/>
+          </a:xfrm>
+          <a:prstGeom prst="rect">
+            <a:avLst/>
+          </a:prstGeom>
+        </p:spPr>
+      </p:pic>
     </p:spTree>
   </p:cSld>
   <p:clrMapOvr>
@@ -6593,7 +5393,7 @@
 </p:sld>
 </file>
 
-<file path=ppt/slides/slide6.xml><?xml version="1.0" encoding="utf-8"?>
+<file path=ppt/slides/slide5.xml><?xml version="1.0" encoding="utf-8"?>
 <p:sld xmlns:a="http://schemas.openxmlformats.org/drawingml/2006/main" xmlns:p="http://schemas.openxmlformats.org/presentationml/2006/main" xmlns:r="http://schemas.openxmlformats.org/officeDocument/2006/relationships">
   <p:cSld>
     <p:bg>
@@ -6642,7 +5442,7 @@
               </a:defRPr>
             </a:pPr>
             <a:r>
-              <a:t>SUCCESS &amp; ROADMAP</a:t>
+              <a:t>PLATFORM SERVICE &amp; SIMULATOR</a:t>
             </a:r>
           </a:p>
         </p:txBody>
@@ -6678,7 +5478,7 @@
               </a:defRPr>
             </a:pPr>
             <a:r>
-              <a:t>05. 성과 및 향후 개선점</a:t>
+              <a:t>04. 분석 결과의 서비스화 및 의사결정 시뮬레이터</a:t>
             </a:r>
           </a:p>
         </p:txBody>
@@ -6762,7 +5562,23 @@
               </a:defRPr>
             </a:pPr>
             <a:r>
-              <a:t>분석 과정에서 잘된 점 (Successes)</a:t>
+              <a:t>시뮬레이터 구현 및 유저 행동 변화 유도</a:t>
+            </a:r>
+          </a:p>
+          <a:p>
+            <a:pPr>
+              <a:spcAft>
+                <a:spcPts val="800"/>
+              </a:spcAft>
+              <a:defRPr sz="1300" b="1">
+                <a:solidFill>
+                  <a:srgbClr val="3B82F6"/>
+                </a:solidFill>
+                <a:latin typeface="Malgun Gothic"/>
+              </a:defRPr>
+            </a:pPr>
+            <a:r>
+              <a:t>■ 의사결정 보조 플랫폼 구현 (Streamlit)</a:t>
             </a:r>
           </a:p>
           <a:p>
@@ -6778,7 +5594,7 @@
               </a:defRPr>
             </a:pPr>
             <a:r>
-              <a:t>■ 1. 비정형 로그의 관계형 정형화 성공</a:t>
+              <a:t>  - Tableau 스타일 다차원 글로벌 필터 연동: 사이드바 필터 변경 즉시 백엔드 SQL 동적 렌더링</a:t>
             </a:r>
           </a:p>
           <a:p>
@@ -6794,7 +5610,7 @@
               </a:defRPr>
             </a:pPr>
             <a:r>
-              <a:t>  - 의미 파악이 어렵던 텍스트 게임 이벤트를 Fact/Dimension 개념의 스타 스키마로 설계하여 다차원 글로벌 분석 쿼리 응답 성능 극대화</a:t>
+              <a:t>  - 실시간 ETL 데모: 유저 파일 업로드 시 정규표현식 파서 및 DB 적재 상황 실시간 애니메이션화</a:t>
             </a:r>
           </a:p>
           <a:p>
@@ -6815,15 +5631,15 @@
               <a:spcAft>
                 <a:spcPts val="800"/>
               </a:spcAft>
-              <a:defRPr sz="1300">
-                <a:solidFill>
-                  <a:srgbClr val="94A3B8"/>
+              <a:defRPr sz="1300" b="1">
+                <a:solidFill>
+                  <a:srgbClr val="FFFFFF"/>
                 </a:solidFill>
                 <a:latin typeface="Malgun Gothic"/>
               </a:defRPr>
             </a:pPr>
             <a:r>
-              <a:t>■ 2. 통계와 머신러닝의 유기적 융합</a:t>
+              <a:t>■ 플레이 스타일 샌드박스 시뮬레이터</a:t>
             </a:r>
           </a:p>
           <a:p>
@@ -6839,7 +5655,7 @@
               </a:defRPr>
             </a:pPr>
             <a:r>
-              <a:t>  - 단순 시각화를 넘어 귀무가설 검정을 통한 원인 진단, K-Means 성향 군집 분류, RF 예측으로 분석의 깊이 확보</a:t>
+              <a:t>  - 유클리드 거리를 사용해 DB 내 932명 중 나와 가장 성격이 비슷한 3명의 실제 유저 자동 추적 매칭</a:t>
             </a:r>
           </a:p>
           <a:p>
@@ -6847,57 +5663,166 @@
               <a:spcAft>
                 <a:spcPts val="800"/>
               </a:spcAft>
-              <a:defRPr sz="1300">
-                <a:solidFill>
-                  <a:srgbClr val="94A3B8"/>
+              <a:defRPr sz="1300" b="1">
+                <a:solidFill>
+                  <a:srgbClr val="FFFFFF"/>
                 </a:solidFill>
                 <a:latin typeface="Malgun Gothic"/>
               </a:defRPr>
             </a:pPr>
+            <a:r>
+              <a:t>  - 의사결정 활용: 유저가 자신의 VPIP, PFR, AF를 조정했을 때 매칭 유저 3인의 30세션 누적 자산 추이 대조 렌더링</a:t>
+            </a:r>
           </a:p>
           <a:p>
             <a:pPr>
               <a:spcAft>
                 <a:spcPts val="800"/>
               </a:spcAft>
-              <a:defRPr sz="1300">
-                <a:solidFill>
-                  <a:srgbClr val="94A3B8"/>
+              <a:defRPr sz="1300" b="1">
+                <a:solidFill>
+                  <a:srgbClr val="FFFFFF"/>
                 </a:solidFill>
                 <a:latin typeface="Malgun Gothic"/>
               </a:defRPr>
             </a:pPr>
             <a:r>
-              <a:t>■ 3. 분석 결과의 MaaS화 (Service화)</a:t>
-            </a:r>
-          </a:p>
-          <a:p>
-            <a:pPr>
-              <a:spcAft>
-                <a:spcPts val="800"/>
-              </a:spcAft>
-              <a:defRPr sz="1300">
-                <a:solidFill>
-                  <a:srgbClr val="94A3B8"/>
-                </a:solidFill>
-                <a:latin typeface="Malgun Gothic"/>
-              </a:defRPr>
-            </a:pPr>
-            <a:r>
-              <a:t>  - 정적 PDF/PPT 분석 보고서에 그치지 않고, 사용자가 직접 수치를 변경해보고 매칭 예측을 해보는 시뮬레이터 플랫폼을 제공하여 실질적 행동 개선 의사결정에 기여</a:t>
-            </a:r>
-          </a:p>
-        </p:txBody>
-      </p:sp>
-      <p:sp>
-        <p:nvSpPr>
-          <p:cNvPr id="6" name="Rounded Rectangle 5"/>
-          <p:cNvSpPr/>
+              <a:t>  - 효과: 유저가 무리한 베팅(Loose-Passive)을 고치지 않으면 몇 판 뒤 파산(이탈)할 확률을 시계열로 직접 모의실험하도록 하여 플레이 전략 개선 유도</a:t>
+            </a:r>
+          </a:p>
+        </p:txBody>
+      </p:sp>
+      <p:pic>
+        <p:nvPicPr>
+          <p:cNvPr id="6" name="Picture 5" descr="tab5_simulator_done_1781002631767.png"/>
+          <p:cNvPicPr>
+            <a:picLocks noChangeAspect="1"/>
+          </p:cNvPicPr>
           <p:nvPr/>
-        </p:nvSpPr>
+        </p:nvPicPr>
+        <p:blipFill>
+          <a:blip r:embed="rId2"/>
+          <a:stretch>
+            <a:fillRect/>
+          </a:stretch>
+        </p:blipFill>
         <p:spPr>
           <a:xfrm>
             <a:off x="6309360" y="1645920"/>
+            <a:ext cx="5120640" cy="3840480"/>
+          </a:xfrm>
+          <a:prstGeom prst="rect">
+            <a:avLst/>
+          </a:prstGeom>
+        </p:spPr>
+      </p:pic>
+    </p:spTree>
+  </p:cSld>
+  <p:clrMapOvr>
+    <a:masterClrMapping/>
+  </p:clrMapOvr>
+</p:sld>
+</file>
+
+<file path=ppt/slides/slide6.xml><?xml version="1.0" encoding="utf-8"?>
+<p:sld xmlns:a="http://schemas.openxmlformats.org/drawingml/2006/main" xmlns:p="http://schemas.openxmlformats.org/presentationml/2006/main" xmlns:r="http://schemas.openxmlformats.org/officeDocument/2006/relationships">
+  <p:cSld>
+    <p:bg>
+      <p:bgPr>
+        <a:solidFill>
+          <a:srgbClr val="0F172A"/>
+        </a:solidFill>
+        <a:effectLst/>
+      </p:bgPr>
+    </p:bg>
+    <p:spTree>
+      <p:nvGrpSpPr>
+        <p:cNvPr id="1" name=""/>
+        <p:cNvGrpSpPr/>
+        <p:nvPr/>
+      </p:nvGrpSpPr>
+      <p:grpSpPr/>
+      <p:sp>
+        <p:nvSpPr>
+          <p:cNvPr id="2" name="TextBox 1"/>
+          <p:cNvSpPr txBox="1"/>
+          <p:nvPr/>
+        </p:nvSpPr>
+        <p:spPr>
+          <a:xfrm>
+            <a:off x="731520" y="365760"/>
+            <a:ext cx="10698480" cy="274320"/>
+          </a:xfrm>
+          <a:prstGeom prst="rect">
+            <a:avLst/>
+          </a:prstGeom>
+          <a:noFill/>
+        </p:spPr>
+        <p:txBody>
+          <a:bodyPr wrap="square" lIns="0" rIns="0" tIns="0" bIns="0">
+            <a:spAutoFit/>
+          </a:bodyPr>
+          <a:lstStyle/>
+          <a:p>
+            <a:pPr>
+              <a:defRPr sz="1000" b="1">
+                <a:solidFill>
+                  <a:srgbClr val="14B8A6"/>
+                </a:solidFill>
+                <a:latin typeface="Arial"/>
+              </a:defRPr>
+            </a:pPr>
+            <a:r>
+              <a:t>SUCCESS &amp; ROADMAP</a:t>
+            </a:r>
+          </a:p>
+        </p:txBody>
+      </p:sp>
+      <p:sp>
+        <p:nvSpPr>
+          <p:cNvPr id="3" name="TextBox 2"/>
+          <p:cNvSpPr txBox="1"/>
+          <p:nvPr/>
+        </p:nvSpPr>
+        <p:spPr>
+          <a:xfrm>
+            <a:off x="731520" y="640080"/>
+            <a:ext cx="10698480" cy="731520"/>
+          </a:xfrm>
+          <a:prstGeom prst="rect">
+            <a:avLst/>
+          </a:prstGeom>
+          <a:noFill/>
+        </p:spPr>
+        <p:txBody>
+          <a:bodyPr wrap="square" lIns="0" rIns="0" tIns="0" bIns="0">
+            <a:spAutoFit/>
+          </a:bodyPr>
+          <a:lstStyle/>
+          <a:p>
+            <a:pPr>
+              <a:defRPr sz="2800" b="1">
+                <a:solidFill>
+                  <a:srgbClr val="FFFFFF"/>
+                </a:solidFill>
+                <a:latin typeface="Malgun Gothic"/>
+              </a:defRPr>
+            </a:pPr>
+            <a:r>
+              <a:t>05. 성과 및 향후 고도화 로드맵</a:t>
+            </a:r>
+          </a:p>
+        </p:txBody>
+      </p:sp>
+      <p:sp>
+        <p:nvSpPr>
+          <p:cNvPr id="4" name="Rounded Rectangle 3"/>
+          <p:cNvSpPr/>
+          <p:nvPr/>
+        </p:nvSpPr>
+        <p:spPr>
+          <a:xfrm>
+            <a:off x="731520" y="1645920"/>
             <a:ext cx="5120640" cy="4389120"/>
           </a:xfrm>
           <a:prstGeom prst="roundRect">
@@ -6936,13 +5861,13 @@
       </p:sp>
       <p:sp>
         <p:nvSpPr>
-          <p:cNvPr id="7" name="TextBox 6"/>
+          <p:cNvPr id="5" name="TextBox 4"/>
           <p:cNvSpPr txBox="1"/>
           <p:nvPr/>
         </p:nvSpPr>
         <p:spPr>
           <a:xfrm>
-            <a:off x="6583680" y="1920240"/>
+            <a:off x="1005840" y="1920240"/>
             <a:ext cx="4572000" cy="3840480"/>
           </a:xfrm>
           <a:prstGeom prst="rect">
@@ -6968,7 +5893,7 @@
               </a:defRPr>
             </a:pPr>
             <a:r>
-              <a:t>개선 필요 사항 및 향후 고도화 로드맵</a:t>
+              <a:t>분석 과정의 성과 및 향후 개선 사항</a:t>
             </a:r>
           </a:p>
           <a:p>
@@ -6984,7 +5909,39 @@
               </a:defRPr>
             </a:pPr>
             <a:r>
-              <a:t>■ 1. 통계적 표본 불균형 보완 전략 수립</a:t>
+              <a:t>■ 분석 과정에서 잘된 점 (Successes)</a:t>
+            </a:r>
+          </a:p>
+          <a:p>
+            <a:pPr>
+              <a:spcAft>
+                <a:spcPts val="800"/>
+              </a:spcAft>
+              <a:defRPr sz="1300" b="1">
+                <a:solidFill>
+                  <a:srgbClr val="FFFFFF"/>
+                </a:solidFill>
+                <a:latin typeface="Malgun Gothic"/>
+              </a:defRPr>
+            </a:pPr>
+            <a:r>
+              <a:t>  - 비정형 데이터의 RDBMS 정형화: 자유 텍스트 로그를 Fact/Dimension 스타 스키마로 설계하여 다차원 글로벌 쿼리 성능 극대화</a:t>
+            </a:r>
+          </a:p>
+          <a:p>
+            <a:pPr>
+              <a:spcAft>
+                <a:spcPts val="800"/>
+              </a:spcAft>
+              <a:defRPr sz="1300" b="1">
+                <a:solidFill>
+                  <a:srgbClr val="FFFFFF"/>
+                </a:solidFill>
+                <a:latin typeface="Malgun Gothic"/>
+              </a:defRPr>
+            </a:pPr>
+            <a:r>
+              <a:t>  - 분석의 서비스화(MaaS) 성공: 단방향 수치 요약 보고서에 그치지 않고 인터랙티브 시뮬레이션 웹서비스로 상용 배포하여 데이터 활용성 극대화</a:t>
             </a:r>
           </a:p>
           <a:p>
@@ -6999,8 +5956,21 @@
                 <a:latin typeface="Malgun Gothic"/>
               </a:defRPr>
             </a:pPr>
-            <a:r>
-              <a:t>  - A/B 테스트에서 기각 원인이 된 대조군 표본 수 부족 해결</a:t>
+          </a:p>
+          <a:p>
+            <a:pPr>
+              <a:spcAft>
+                <a:spcPts val="800"/>
+              </a:spcAft>
+              <a:defRPr sz="1300">
+                <a:solidFill>
+                  <a:srgbClr val="94A3B8"/>
+                </a:solidFill>
+                <a:latin typeface="Malgun Gothic"/>
+              </a:defRPr>
+            </a:pPr>
+            <a:r>
+              <a:t>■ 개선이 필요한 점 및 향후 계획 (Roadmap)</a:t>
             </a:r>
           </a:p>
           <a:p>
@@ -7016,52 +5986,7 @@
               </a:defRPr>
             </a:pPr>
             <a:r>
-              <a:t>  - *대안*: 성향점수 매칭(PSM) 기법을 통한 통제군 형성 및 부트스트랩(Bootstrap) 리샘플링을 통한 신뢰구간 복원 적용 계획</a:t>
-            </a:r>
-          </a:p>
-          <a:p>
-            <a:pPr>
-              <a:spcAft>
-                <a:spcPts val="800"/>
-              </a:spcAft>
-              <a:defRPr sz="1300">
-                <a:solidFill>
-                  <a:srgbClr val="94A3B8"/>
-                </a:solidFill>
-                <a:latin typeface="Malgun Gothic"/>
-              </a:defRPr>
-            </a:pPr>
-          </a:p>
-          <a:p>
-            <a:pPr>
-              <a:spcAft>
-                <a:spcPts val="800"/>
-              </a:spcAft>
-              <a:defRPr sz="1300">
-                <a:solidFill>
-                  <a:srgbClr val="94A3B8"/>
-                </a:solidFill>
-                <a:latin typeface="Malgun Gothic"/>
-              </a:defRPr>
-            </a:pPr>
-            <a:r>
-              <a:t>■ 2. 대규모 로그 스트리밍을 위한 확장형 파이프라인</a:t>
-            </a:r>
-          </a:p>
-          <a:p>
-            <a:pPr>
-              <a:spcAft>
-                <a:spcPts val="800"/>
-              </a:spcAft>
-              <a:defRPr sz="1300">
-                <a:solidFill>
-                  <a:srgbClr val="94A3B8"/>
-                </a:solidFill>
-                <a:latin typeface="Malgun Gothic"/>
-              </a:defRPr>
-            </a:pPr>
-            <a:r>
-              <a:t>  - 단일 RDBMS의 동시성 락 및 용량 병목 극복</a:t>
+              <a:t>  - 통계적 신뢰도 보완: T-Test의 대조군 표본 부족 현상 해결을 위해 성향점수 매칭(PSM) 및 부트스트랩 리샘플링 적용 추진</a:t>
             </a:r>
           </a:p>
           <a:p>
@@ -7077,11 +6002,35 @@
               </a:defRPr>
             </a:pPr>
             <a:r>
-              <a:t>  - *대안*: 실시간 수집을 위한 Apache Kafka 큐 및 실시간 처리를 위한 Apache Spark 분산 파이프라인 설계, 클라우드 DW(BigQuery)로의 적재 이전 로드맵 구상</a:t>
-            </a:r>
-          </a:p>
-        </p:txBody>
-      </p:sp>
+              <a:t>  - 아키텍처 확장: 단일 RDBMS 동시성 병목 우려 대응을 위한 실시간 Apache Kafka 큐, Apache Spark 분산 엔진 도입 및 GCP BigQuery 클라우드 DW 마이그레이션 로드맵 수립</a:t>
+            </a:r>
+          </a:p>
+        </p:txBody>
+      </p:sp>
+      <p:pic>
+        <p:nvPicPr>
+          <p:cNvPr id="6" name="Picture 5" descr="tab3_funnel_cohort_1781002583397.png"/>
+          <p:cNvPicPr>
+            <a:picLocks noChangeAspect="1"/>
+          </p:cNvPicPr>
+          <p:nvPr/>
+        </p:nvPicPr>
+        <p:blipFill>
+          <a:blip r:embed="rId2"/>
+          <a:stretch>
+            <a:fillRect/>
+          </a:stretch>
+        </p:blipFill>
+        <p:spPr>
+          <a:xfrm>
+            <a:off x="6309360" y="1645920"/>
+            <a:ext cx="5120640" cy="3840480"/>
+          </a:xfrm>
+          <a:prstGeom prst="rect">
+            <a:avLst/>
+          </a:prstGeom>
+        </p:spPr>
+      </p:pic>
     </p:spTree>
   </p:cSld>
   <p:clrMapOvr>

</xml_diff>

<commit_message>
Fix slide card layout text overflow and adjust image sizing
</commit_message>
<xml_diff>
--- a/poker_analytics_presentation.pptx
+++ b/poker_analytics_presentation.pptx
@@ -627,7 +627,7 @@
           <a:p/>
           <a:p>
             <a:r>
-              <a:t>이 데이터를 근거로, 저는 플랫폼 서비스 기획에 대해 매우 구체적인 '의사결정'을 내렸습니다. 단순히 '소심하게 베팅하지 마십시오'라는 글로 된 가이드를 주는 데 그치지 않고, 유저가 직접 마우스로 수치를 조정하며 스스로의 미래 자산 추이를 확인하고 습관을 교정할 수 있는 '실시간 샌드박스 시뮬레이터 기능을 대시보드 플랫폼에 핵심 스펙으로 포함하여 상용 배포하기로 결정'한 것입니다."</a:t>
+              <a:t>이 데이터를 근거로, 저는 첫 번째 '핵심 의사결정'을 내렸습니다. 단순히 '소심하게 베팅하지 마십시오'라는 글로 된 가이드를 주는 데 그치지 않고, 유저가 직접 마우스로 수치를 조정하며 스스로의 미래 자산 추이를 확인하고 습관을 교정할 수 있는 '실시간 샌드박스 시뮬레이터 기능을 대시보드 플랫폼에 핵심 스펙으로 포함하여 상용 배포하기로 결정'한 것입니다."</a:t>
             </a:r>
           </a:p>
           <a:p/>
@@ -718,7 +718,7 @@
           </a:p>
           <a:p>
             <a:r>
-              <a:t>"두 번째로 활용한 데이터 스펙과 파이프라인 구축 과정에서 제가 수행한 역할입니다.</a:t>
+              <a:t>"두 번째로 활용한 데이터 스펙과 데이터 파이프라인 구축 과정에서 제가 수행한 역할입니다.</a:t>
             </a:r>
           </a:p>
           <a:p/>
@@ -984,7 +984,7 @@
           <a:p/>
           <a:p>
             <a:r>
-              <a:t>만약 유저가 돈을 크게 잃고 이탈할 수밖에 없는 Loose-Passive 상태를 설정하면, 화면에는 3인의 유저 자산 그래프가 가파르게 우하향하며 파산하는 모습이 그려집니다. 유저는 이 시뮬레이션을 통해 본인의 잘못된 플레이 전략이 미래 자산에 미칠 충격을 직접 체감하고, 지표를 개선(VPIP 15~22%, AF 2.0~3.5)하여 우상향하는 그래프를 매칭받도록 본인의 전략 의사결정을 수정하게 됩니다."</a:t>
+              <a:t>만약 유저가 돈을 크게 잃고 이탈할 수밖에 없는 Loose-Passive 상태를 설정하면, 화면에는 3인의 유저 자산 그래프가 가파르게 우하향하며 파산하는 모습을 직접 목격하게 됩니다. 유저는 이 시뮬레이션을 통해 본인의 잘못된 플레이 전략이 미래 자산에 미칠 충격을 직접 체감하고, 지표를 개선(VPIP 15~22%, AF 2.0~3.5)하여 우상향하는 그래프를 매칭받도록 본인의 플레이 전략을 스스로 변경하는 행동 개선 의사결정을 내릴 수 있게 됩니다."</a:t>
             </a:r>
           </a:p>
           <a:p/>
@@ -4376,8 +4376,8 @@
         </p:nvSpPr>
         <p:spPr>
           <a:xfrm>
-            <a:off x="731520" y="1645920"/>
-            <a:ext cx="5120640" cy="4389120"/>
+            <a:off x="731520" y="1371600"/>
+            <a:ext cx="5120640" cy="4754880"/>
           </a:xfrm>
           <a:prstGeom prst="roundRect">
             <a:avLst/>
@@ -4421,8 +4421,8 @@
         </p:nvSpPr>
         <p:spPr>
           <a:xfrm>
-            <a:off x="1005840" y="1920240"/>
-            <a:ext cx="4572000" cy="3840480"/>
+            <a:off x="960120" y="1600200"/>
+            <a:ext cx="4663440" cy="4297680"/>
           </a:xfrm>
           <a:prstGeom prst="rect">
             <a:avLst/>
@@ -4437,9 +4437,9 @@
           <a:p>
             <a:pPr>
               <a:spcAft>
-                <a:spcPts val="1400"/>
+                <a:spcPts val="1000"/>
               </a:spcAft>
-              <a:defRPr sz="1800" b="1">
+              <a:defRPr sz="1600" b="1">
                 <a:solidFill>
                   <a:srgbClr val="14B8A6"/>
                 </a:solidFill>
@@ -4453,9 +4453,9 @@
           <a:p>
             <a:pPr>
               <a:spcAft>
-                <a:spcPts val="800"/>
+                <a:spcPts val="400"/>
               </a:spcAft>
-              <a:defRPr sz="1300">
+              <a:defRPr sz="1100">
                 <a:solidFill>
                   <a:srgbClr val="94A3B8"/>
                 </a:solidFill>
@@ -4469,9 +4469,9 @@
           <a:p>
             <a:pPr>
               <a:spcAft>
-                <a:spcPts val="800"/>
+                <a:spcPts val="400"/>
               </a:spcAft>
-              <a:defRPr sz="1300">
+              <a:defRPr sz="1100">
                 <a:solidFill>
                   <a:srgbClr val="94A3B8"/>
                 </a:solidFill>
@@ -4479,15 +4479,15 @@
               </a:defRPr>
             </a:pPr>
             <a:r>
-              <a:t>  - iGaming 서비스의 핵심은 유저 파산 및 이탈(Churn) 방어</a:t>
+              <a:t>  - iGaming 플랫폼의 핵심 과제: 유저 파산 및 이탈(Churn) 방어</a:t>
             </a:r>
           </a:p>
           <a:p>
             <a:pPr>
               <a:spcAft>
-                <a:spcPts val="800"/>
+                <a:spcPts val="400"/>
               </a:spcAft>
-              <a:defRPr sz="1300">
+              <a:defRPr sz="1100">
                 <a:solidFill>
                   <a:srgbClr val="94A3B8"/>
                 </a:solidFill>
@@ -4495,15 +4495,15 @@
               </a:defRPr>
             </a:pPr>
             <a:r>
-              <a:t>  - 올바른 플레이 가이드 부재로 인한 급격한 유저 이탈 직면</a:t>
+              <a:t>  - 올바른 플레이 가이드 부재로 인한 급격한 고객 이탈 직면</a:t>
             </a:r>
           </a:p>
           <a:p>
             <a:pPr>
               <a:spcAft>
-                <a:spcPts val="800"/>
+                <a:spcPts val="400"/>
               </a:spcAft>
-              <a:defRPr sz="1300">
+              <a:defRPr sz="1100">
                 <a:solidFill>
                   <a:srgbClr val="94A3B8"/>
                 </a:solidFill>
@@ -4514,9 +4514,9 @@
           <a:p>
             <a:pPr>
               <a:spcAft>
-                <a:spcPts val="800"/>
+                <a:spcPts val="400"/>
               </a:spcAft>
-              <a:defRPr sz="1300">
+              <a:defRPr sz="1100">
                 <a:solidFill>
                   <a:srgbClr val="94A3B8"/>
                 </a:solidFill>
@@ -4530,9 +4530,9 @@
           <a:p>
             <a:pPr>
               <a:spcAft>
-                <a:spcPts val="800"/>
+                <a:spcPts val="400"/>
               </a:spcAft>
-              <a:defRPr sz="1300">
+              <a:defRPr sz="1100">
                 <a:solidFill>
                   <a:srgbClr val="94A3B8"/>
                 </a:solidFill>
@@ -4540,15 +4540,15 @@
               </a:defRPr>
             </a:pPr>
             <a:r>
-              <a:t>  - VPIP, PFR, AF 지표 마트 구축 및 다차원 현황 분석</a:t>
+              <a:t>  - VPIP, PFR, AF 지표 마트 구축을 통한 다차원 현황 분석</a:t>
             </a:r>
           </a:p>
           <a:p>
             <a:pPr>
               <a:spcAft>
-                <a:spcPts val="800"/>
+                <a:spcPts val="400"/>
               </a:spcAft>
-              <a:defRPr sz="1300">
+              <a:defRPr sz="1100">
                 <a:solidFill>
                   <a:srgbClr val="94A3B8"/>
                 </a:solidFill>
@@ -4556,15 +4556,15 @@
               </a:defRPr>
             </a:pPr>
             <a:r>
-              <a:t>  - 수동적 진입 유저(Loose-Passive)가 가장 심각한 칩 손실</a:t>
+              <a:t>  - 소극적 유저(Loose-Passive)가 가장 심각한 수준인</a:t>
             </a:r>
           </a:p>
           <a:p>
             <a:pPr>
               <a:spcAft>
-                <a:spcPts val="800"/>
+                <a:spcPts val="400"/>
               </a:spcAft>
-              <a:defRPr sz="1300">
+              <a:defRPr sz="1100">
                 <a:solidFill>
                   <a:srgbClr val="94A3B8"/>
                 </a:solidFill>
@@ -4572,15 +4572,15 @@
               </a:defRPr>
             </a:pPr>
             <a:r>
-              <a:t>    (평균 -16,393 칩스 적자)을 내며 이탈한다는 사실 규명</a:t>
+              <a:t>    평균 -16,393 칩스 적자를 겪으며 파산/이탈함을 규명</a:t>
             </a:r>
           </a:p>
           <a:p>
             <a:pPr>
               <a:spcAft>
-                <a:spcPts val="800"/>
+                <a:spcPts val="400"/>
               </a:spcAft>
-              <a:defRPr sz="1300">
+              <a:defRPr sz="1100">
                 <a:solidFill>
                   <a:srgbClr val="94A3B8"/>
                 </a:solidFill>
@@ -4591,9 +4591,9 @@
           <a:p>
             <a:pPr>
               <a:spcAft>
-                <a:spcPts val="800"/>
+                <a:spcPts val="400"/>
               </a:spcAft>
-              <a:defRPr sz="1300" b="1">
+              <a:defRPr sz="1100" b="1">
                 <a:solidFill>
                   <a:srgbClr val="FFFFFF"/>
                 </a:solidFill>
@@ -4607,9 +4607,9 @@
           <a:p>
             <a:pPr>
               <a:spcAft>
-                <a:spcPts val="800"/>
+                <a:spcPts val="400"/>
               </a:spcAft>
-              <a:defRPr sz="1300">
+              <a:defRPr sz="1100">
                 <a:solidFill>
                   <a:srgbClr val="94A3B8"/>
                 </a:solidFill>
@@ -4617,15 +4617,15 @@
               </a:defRPr>
             </a:pPr>
             <a:r>
-              <a:t>  - 유저 이탈을 막기 위해 단순히 공식을 나열하는 대신,</a:t>
+              <a:t>  - 유저 이탈을 방지하고 전략 개선을 유도하기 위해,</a:t>
             </a:r>
           </a:p>
           <a:p>
             <a:pPr>
               <a:spcAft>
-                <a:spcPts val="800"/>
+                <a:spcPts val="400"/>
               </a:spcAft>
-              <a:defRPr sz="1300" b="1">
+              <a:defRPr sz="1100" b="1">
                 <a:solidFill>
                   <a:srgbClr val="FFFFFF"/>
                 </a:solidFill>
@@ -4633,7 +4633,7 @@
               </a:defRPr>
             </a:pPr>
             <a:r>
-              <a:t>  - '유저가 본인의 지표를 변경했을 때 미래의 자산 파산 추이를 모의실험해볼 수 있는 실시간 시뮬레이션(Sandbox) 기능을 대시보드 플랫폼에 신설 및 상용 배포하기로 결정'함.</a:t>
+              <a:t>  - '본인 지표 변경 시 미래의 자산 파산 추이를 모의실험해볼 수 있는 실시간 시뮬레이션(Sandbox) 기능을 대시보드에 신설 및 상용 배포 결정'함.</a:t>
             </a:r>
           </a:p>
         </p:txBody>
@@ -4654,7 +4654,7 @@
         </p:blipFill>
         <p:spPr>
           <a:xfrm>
-            <a:off x="6309360" y="1645920"/>
+            <a:off x="6309360" y="1371600"/>
             <a:ext cx="5120640" cy="3840480"/>
           </a:xfrm>
           <a:prstGeom prst="rect">
@@ -4768,8 +4768,8 @@
         </p:nvSpPr>
         <p:spPr>
           <a:xfrm>
-            <a:off x="731520" y="1645920"/>
-            <a:ext cx="5120640" cy="4389120"/>
+            <a:off x="731520" y="1371600"/>
+            <a:ext cx="5120640" cy="4754880"/>
           </a:xfrm>
           <a:prstGeom prst="roundRect">
             <a:avLst/>
@@ -4813,8 +4813,8 @@
         </p:nvSpPr>
         <p:spPr>
           <a:xfrm>
-            <a:off x="1005840" y="1920240"/>
-            <a:ext cx="4572000" cy="3840480"/>
+            <a:off x="960120" y="1600200"/>
+            <a:ext cx="4663440" cy="4297680"/>
           </a:xfrm>
           <a:prstGeom prst="rect">
             <a:avLst/>
@@ -4829,9 +4829,9 @@
           <a:p>
             <a:pPr>
               <a:spcAft>
-                <a:spcPts val="1400"/>
+                <a:spcPts val="1000"/>
               </a:spcAft>
-              <a:defRPr sz="1800" b="1">
+              <a:defRPr sz="1600" b="1">
                 <a:solidFill>
                   <a:srgbClr val="14B8A6"/>
                 </a:solidFill>
@@ -4845,9 +4845,9 @@
           <a:p>
             <a:pPr>
               <a:spcAft>
-                <a:spcPts val="800"/>
+                <a:spcPts val="400"/>
               </a:spcAft>
-              <a:defRPr sz="1300">
+              <a:defRPr sz="1100">
                 <a:solidFill>
                   <a:srgbClr val="94A3B8"/>
                 </a:solidFill>
@@ -4861,9 +4861,9 @@
           <a:p>
             <a:pPr>
               <a:spcAft>
-                <a:spcPts val="800"/>
+                <a:spcPts val="400"/>
               </a:spcAft>
-              <a:defRPr sz="1300">
+              <a:defRPr sz="1100">
                 <a:solidFill>
                   <a:srgbClr val="94A3B8"/>
                 </a:solidFill>
@@ -4877,9 +4877,9 @@
           <a:p>
             <a:pPr>
               <a:spcAft>
-                <a:spcPts val="800"/>
+                <a:spcPts val="400"/>
               </a:spcAft>
-              <a:defRPr sz="1300" b="1">
+              <a:defRPr sz="1100" b="1">
                 <a:solidFill>
                   <a:srgbClr val="FFFFFF"/>
                 </a:solidFill>
@@ -4893,9 +4893,9 @@
           <a:p>
             <a:pPr>
               <a:spcAft>
-                <a:spcPts val="800"/>
+                <a:spcPts val="400"/>
               </a:spcAft>
-              <a:defRPr sz="1300" b="1">
+              <a:defRPr sz="1100" b="1">
                 <a:solidFill>
                   <a:srgbClr val="FFFFFF"/>
                 </a:solidFill>
@@ -4909,9 +4909,9 @@
           <a:p>
             <a:pPr>
               <a:spcAft>
-                <a:spcPts val="800"/>
+                <a:spcPts val="400"/>
               </a:spcAft>
-              <a:defRPr sz="1300">
+              <a:defRPr sz="1100">
                 <a:solidFill>
                   <a:srgbClr val="94A3B8"/>
                 </a:solidFill>
@@ -4922,9 +4922,9 @@
           <a:p>
             <a:pPr>
               <a:spcAft>
-                <a:spcPts val="800"/>
+                <a:spcPts val="400"/>
               </a:spcAft>
-              <a:defRPr sz="1300">
+              <a:defRPr sz="1100">
                 <a:solidFill>
                   <a:srgbClr val="94A3B8"/>
                 </a:solidFill>
@@ -4938,9 +4938,9 @@
           <a:p>
             <a:pPr>
               <a:spcAft>
-                <a:spcPts val="800"/>
+                <a:spcPts val="400"/>
               </a:spcAft>
-              <a:defRPr sz="1300" b="1">
+              <a:defRPr sz="1100" b="1">
                 <a:solidFill>
                   <a:srgbClr val="FFFFFF"/>
                 </a:solidFill>
@@ -4948,15 +4948,31 @@
               </a:defRPr>
             </a:pPr>
             <a:r>
-              <a:t>  - 정규표현식(Regex) 파서 설계: 줄글 형태의 원천 텍스트에서 베팅 금액, 플레이어명, 액션 단계를 필터 오차 없이 파싱</a:t>
+              <a:t>  - Regex 파서 설계: 텍스트 형태의 원천 로그에서</a:t>
             </a:r>
           </a:p>
           <a:p>
             <a:pPr>
               <a:spcAft>
-                <a:spcPts val="800"/>
+                <a:spcPts val="400"/>
               </a:spcAft>
-              <a:defRPr sz="1300" b="1">
+              <a:defRPr sz="1100">
+                <a:solidFill>
+                  <a:srgbClr val="94A3B8"/>
+                </a:solidFill>
+                <a:latin typeface="Malgun Gothic"/>
+              </a:defRPr>
+            </a:pPr>
+            <a:r>
+              <a:t>    베팅액, 플레이어명, 액션 단계를 필터 오차 없이 파싱</a:t>
+            </a:r>
+          </a:p>
+          <a:p>
+            <a:pPr>
+              <a:spcAft>
+                <a:spcPts val="400"/>
+              </a:spcAft>
+              <a:defRPr sz="1100" b="1">
                 <a:solidFill>
                   <a:srgbClr val="FFFFFF"/>
                 </a:solidFill>
@@ -4964,15 +4980,31 @@
               </a:defRPr>
             </a:pPr>
             <a:r>
-              <a:t>  - 스타 스키마(Star Schema) 모델링: DW 설계 표준인 Fact(`hands`, `actions`) 및 Dimension(`players`, `tournaments`) 구조 설계</a:t>
+              <a:t>  - 스타 스키마 모델링: DW 설계 표준인 Fact(`hands`,</a:t>
             </a:r>
           </a:p>
           <a:p>
             <a:pPr>
               <a:spcAft>
-                <a:spcPts val="800"/>
+                <a:spcPts val="400"/>
               </a:spcAft>
-              <a:defRPr sz="1300" b="1">
+              <a:defRPr sz="1100">
+                <a:solidFill>
+                  <a:srgbClr val="94A3B8"/>
+                </a:solidFill>
+                <a:latin typeface="Malgun Gothic"/>
+              </a:defRPr>
+            </a:pPr>
+            <a:r>
+              <a:t>    `actions`) 및 Dimension(`players`, `tournaments`) 구조 설계</a:t>
+            </a:r>
+          </a:p>
+          <a:p>
+            <a:pPr>
+              <a:spcAft>
+                <a:spcPts val="400"/>
+              </a:spcAft>
+              <a:defRPr sz="1100" b="1">
                 <a:solidFill>
                   <a:srgbClr val="FFFFFF"/>
                 </a:solidFill>
@@ -4980,7 +5012,23 @@
               </a:defRPr>
             </a:pPr>
             <a:r>
-              <a:t>  - 이중 DB 호환성: 가벼운 SQLite 파일 DB와 상용 PostgreSQL DB 간에 환경 변수 1개로 적재 및 조회를 전환하는 호환 레이어 구현</a:t>
+              <a:t>  - 이중 DB 호환: SQLite 로컬 DB와 PostgreSQL 상용 DB 간에</a:t>
+            </a:r>
+          </a:p>
+          <a:p>
+            <a:pPr>
+              <a:spcAft>
+                <a:spcPts val="400"/>
+              </a:spcAft>
+              <a:defRPr sz="1100">
+                <a:solidFill>
+                  <a:srgbClr val="94A3B8"/>
+                </a:solidFill>
+                <a:latin typeface="Malgun Gothic"/>
+              </a:defRPr>
+            </a:pPr>
+            <a:r>
+              <a:t>    환경 변수 하나로 스위칭 전환 가능한 호환 커넥터 구현</a:t>
             </a:r>
           </a:p>
         </p:txBody>
@@ -5001,7 +5049,7 @@
         </p:blipFill>
         <p:spPr>
           <a:xfrm>
-            <a:off x="6309360" y="1645920"/>
+            <a:off x="6309360" y="1371600"/>
             <a:ext cx="5120640" cy="3840480"/>
           </a:xfrm>
           <a:prstGeom prst="rect">
@@ -5115,8 +5163,8 @@
         </p:nvSpPr>
         <p:spPr>
           <a:xfrm>
-            <a:off x="731520" y="1645920"/>
-            <a:ext cx="5120640" cy="4389120"/>
+            <a:off x="731520" y="1371600"/>
+            <a:ext cx="5120640" cy="4754880"/>
           </a:xfrm>
           <a:prstGeom prst="roundRect">
             <a:avLst/>
@@ -5160,8 +5208,8 @@
         </p:nvSpPr>
         <p:spPr>
           <a:xfrm>
-            <a:off x="1005840" y="1920240"/>
-            <a:ext cx="4572000" cy="3840480"/>
+            <a:off x="960120" y="1600200"/>
+            <a:ext cx="4663440" cy="4297680"/>
           </a:xfrm>
           <a:prstGeom prst="rect">
             <a:avLst/>
@@ -5176,9 +5224,9 @@
           <a:p>
             <a:pPr>
               <a:spcAft>
-                <a:spcPts val="1400"/>
+                <a:spcPts val="1000"/>
               </a:spcAft>
-              <a:defRPr sz="1800" b="1">
+              <a:defRPr sz="1600" b="1">
                 <a:solidFill>
                   <a:srgbClr val="14B8A6"/>
                 </a:solidFill>
@@ -5192,9 +5240,9 @@
           <a:p>
             <a:pPr>
               <a:spcAft>
-                <a:spcPts val="800"/>
+                <a:spcPts val="400"/>
               </a:spcAft>
-              <a:defRPr sz="1300">
+              <a:defRPr sz="1100">
                 <a:solidFill>
                   <a:srgbClr val="94A3B8"/>
                 </a:solidFill>
@@ -5208,9 +5256,9 @@
           <a:p>
             <a:pPr>
               <a:spcAft>
-                <a:spcPts val="800"/>
+                <a:spcPts val="400"/>
               </a:spcAft>
-              <a:defRPr sz="1300">
+              <a:defRPr sz="1100">
                 <a:solidFill>
                   <a:srgbClr val="94A3B8"/>
                 </a:solidFill>
@@ -5218,15 +5266,15 @@
               </a:defRPr>
             </a:pPr>
             <a:r>
-              <a:t>  - 가설: 프리미엄 패를 쥐었을 때 선공(A)으로 진입한 집단이 단순 콜(B)로만 진입한 집단보다 수익이 유의미하게 높을 것이다.</a:t>
+              <a:t>  - 가설: 프리미엄 카드 진입 시 선공(A)이 소극적 콜(B)보다 수익이 높을 것이다.</a:t>
             </a:r>
           </a:p>
           <a:p>
             <a:pPr>
               <a:spcAft>
-                <a:spcPts val="800"/>
+                <a:spcPts val="400"/>
               </a:spcAft>
-              <a:defRPr sz="1300">
+              <a:defRPr sz="1100">
                 <a:solidFill>
                   <a:srgbClr val="94A3B8"/>
                 </a:solidFill>
@@ -5240,9 +5288,9 @@
           <a:p>
             <a:pPr>
               <a:spcAft>
-                <a:spcPts val="800"/>
+                <a:spcPts val="400"/>
               </a:spcAft>
-              <a:defRPr sz="1300">
+              <a:defRPr sz="1100">
                 <a:solidFill>
                   <a:srgbClr val="94A3B8"/>
                 </a:solidFill>
@@ -5253,9 +5301,9 @@
           <a:p>
             <a:pPr>
               <a:spcAft>
-                <a:spcPts val="800"/>
+                <a:spcPts val="400"/>
               </a:spcAft>
-              <a:defRPr sz="1300" b="1">
+              <a:defRPr sz="1100" b="1">
                 <a:solidFill>
                   <a:srgbClr val="FFFFFF"/>
                 </a:solidFill>
@@ -5269,9 +5317,9 @@
           <a:p>
             <a:pPr>
               <a:spcAft>
-                <a:spcPts val="800"/>
+                <a:spcPts val="400"/>
               </a:spcAft>
-              <a:defRPr sz="1300">
+              <a:defRPr sz="1100">
                 <a:solidFill>
                   <a:srgbClr val="94A3B8"/>
                 </a:solidFill>
@@ -5279,15 +5327,15 @@
               </a:defRPr>
             </a:pPr>
             <a:r>
-              <a:t>  - 분석 결과 기각되었으나 단순히 기각으로 결론짓지 않고,</a:t>
+              <a:t>  - 대조군(소극 진입)의 표본수가 극히 작아 생긴 통계 오류(검정력 부족) 진단</a:t>
             </a:r>
           </a:p>
           <a:p>
             <a:pPr>
               <a:spcAft>
-                <a:spcPts val="800"/>
+                <a:spcPts val="400"/>
               </a:spcAft>
-              <a:defRPr sz="1300" b="1">
+              <a:defRPr sz="1100" b="1">
                 <a:solidFill>
                   <a:srgbClr val="FFFFFF"/>
                 </a:solidFill>
@@ -5295,15 +5343,15 @@
               </a:defRPr>
             </a:pPr>
             <a:r>
-              <a:t>  - '대조군인 콜 진입 집합의 표본 크기가 극히 적어 통계적 검정력이 부족했음을 정밀 진단하여, 유저에게 왜곡된 팩트를 가이드하는 대신 표본 보완책(성향점수 매칭, 부트스트랩)을 분석 엔진에 즉각 주입하기 전까지 비즈니스 판단을 유보하고 분석 방식을 보완하는 결정을 내림'.</a:t>
+              <a:t>  - '통계적 신뢰성을 가질 때까지 성급한 비즈니스 지침 판단을 유보하고, 성향점수 매칭(PSM) 및 부트스트랩을 도입하여 통계 엔진을 전면 보완하기로 의사결정'함.</a:t>
             </a:r>
           </a:p>
           <a:p>
             <a:pPr>
               <a:spcAft>
-                <a:spcPts val="800"/>
+                <a:spcPts val="400"/>
               </a:spcAft>
-              <a:defRPr sz="1300">
+              <a:defRPr sz="1100">
                 <a:solidFill>
                   <a:srgbClr val="94A3B8"/>
                 </a:solidFill>
@@ -5314,9 +5362,9 @@
           <a:p>
             <a:pPr>
               <a:spcAft>
-                <a:spcPts val="800"/>
+                <a:spcPts val="400"/>
               </a:spcAft>
-              <a:defRPr sz="1300">
+              <a:defRPr sz="1100">
                 <a:solidFill>
                   <a:srgbClr val="94A3B8"/>
                 </a:solidFill>
@@ -5330,9 +5378,9 @@
           <a:p>
             <a:pPr>
               <a:spcAft>
-                <a:spcPts val="800"/>
+                <a:spcPts val="400"/>
               </a:spcAft>
-              <a:defRPr sz="1300">
+              <a:defRPr sz="1100">
                 <a:solidFill>
                   <a:srgbClr val="94A3B8"/>
                 </a:solidFill>
@@ -5340,15 +5388,15 @@
               </a:defRPr>
             </a:pPr>
             <a:r>
-              <a:t>  - K-Means 알고리즘으로 유저 4대 성향 코호트 자동 분류</a:t>
+              <a:t>  - K-Means 알고리즘 적용: 유저 4대 성향 코호트 자동 분류</a:t>
             </a:r>
           </a:p>
           <a:p>
             <a:pPr>
               <a:spcAft>
-                <a:spcPts val="800"/>
+                <a:spcPts val="400"/>
               </a:spcAft>
-              <a:defRPr sz="1300">
+              <a:defRPr sz="1100">
                 <a:solidFill>
                   <a:srgbClr val="94A3B8"/>
                 </a:solidFill>
@@ -5356,7 +5404,7 @@
               </a:defRPr>
             </a:pPr>
             <a:r>
-              <a:t>  - Random Forest를 연동해 유저 지표 기반 흑자 예측 (Accuracy 84%)</a:t>
+              <a:t>  - Random Forest Classifier 연동: 유저 흑자 여부 예측 (Accuracy 84%)</a:t>
             </a:r>
           </a:p>
         </p:txBody>
@@ -5377,7 +5425,7 @@
         </p:blipFill>
         <p:spPr>
           <a:xfrm>
-            <a:off x="6309360" y="1645920"/>
+            <a:off x="6309360" y="1371600"/>
             <a:ext cx="5120640" cy="3840480"/>
           </a:xfrm>
           <a:prstGeom prst="rect">
@@ -5491,8 +5539,8 @@
         </p:nvSpPr>
         <p:spPr>
           <a:xfrm>
-            <a:off x="731520" y="1645920"/>
-            <a:ext cx="5120640" cy="4389120"/>
+            <a:off x="731520" y="1371600"/>
+            <a:ext cx="5120640" cy="4754880"/>
           </a:xfrm>
           <a:prstGeom prst="roundRect">
             <a:avLst/>
@@ -5536,8 +5584,8 @@
         </p:nvSpPr>
         <p:spPr>
           <a:xfrm>
-            <a:off x="1005840" y="1920240"/>
-            <a:ext cx="4572000" cy="3840480"/>
+            <a:off x="960120" y="1600200"/>
+            <a:ext cx="4663440" cy="4297680"/>
           </a:xfrm>
           <a:prstGeom prst="rect">
             <a:avLst/>
@@ -5552,9 +5600,9 @@
           <a:p>
             <a:pPr>
               <a:spcAft>
-                <a:spcPts val="1400"/>
+                <a:spcPts val="1000"/>
               </a:spcAft>
-              <a:defRPr sz="1800" b="1">
+              <a:defRPr sz="1600" b="1">
                 <a:solidFill>
                   <a:srgbClr val="14B8A6"/>
                 </a:solidFill>
@@ -5568,9 +5616,9 @@
           <a:p>
             <a:pPr>
               <a:spcAft>
-                <a:spcPts val="800"/>
+                <a:spcPts val="400"/>
               </a:spcAft>
-              <a:defRPr sz="1300" b="1">
+              <a:defRPr sz="1100" b="1">
                 <a:solidFill>
                   <a:srgbClr val="3B82F6"/>
                 </a:solidFill>
@@ -5584,9 +5632,9 @@
           <a:p>
             <a:pPr>
               <a:spcAft>
-                <a:spcPts val="800"/>
+                <a:spcPts val="400"/>
               </a:spcAft>
-              <a:defRPr sz="1300">
+              <a:defRPr sz="1100">
                 <a:solidFill>
                   <a:srgbClr val="94A3B8"/>
                 </a:solidFill>
@@ -5594,15 +5642,15 @@
               </a:defRPr>
             </a:pPr>
             <a:r>
-              <a:t>  - Tableau 스타일 다차원 글로벌 필터 연동: 사이드바 필터 변경 즉시 백엔드 SQL 동적 렌더링</a:t>
+              <a:t>  - Tableau 스타일 필터: 사이드바 필터 변경 즉시 SQL 동적 렌더링</a:t>
             </a:r>
           </a:p>
           <a:p>
             <a:pPr>
               <a:spcAft>
-                <a:spcPts val="800"/>
+                <a:spcPts val="400"/>
               </a:spcAft>
-              <a:defRPr sz="1300">
+              <a:defRPr sz="1100">
                 <a:solidFill>
                   <a:srgbClr val="94A3B8"/>
                 </a:solidFill>
@@ -5610,15 +5658,15 @@
               </a:defRPr>
             </a:pPr>
             <a:r>
-              <a:t>  - 실시간 ETL 데모: 유저 파일 업로드 시 정규표현식 파서 및 DB 적재 상황 실시간 애니메이션화</a:t>
+              <a:t>  - 실시간 ETL 데모: 업로드 시 파서 작동 및 실시간 진행바 표시</a:t>
             </a:r>
           </a:p>
           <a:p>
             <a:pPr>
               <a:spcAft>
-                <a:spcPts val="800"/>
+                <a:spcPts val="400"/>
               </a:spcAft>
-              <a:defRPr sz="1300">
+              <a:defRPr sz="1100">
                 <a:solidFill>
                   <a:srgbClr val="94A3B8"/>
                 </a:solidFill>
@@ -5629,9 +5677,9 @@
           <a:p>
             <a:pPr>
               <a:spcAft>
-                <a:spcPts val="800"/>
+                <a:spcPts val="400"/>
               </a:spcAft>
-              <a:defRPr sz="1300" b="1">
+              <a:defRPr sz="1100" b="1">
                 <a:solidFill>
                   <a:srgbClr val="FFFFFF"/>
                 </a:solidFill>
@@ -5645,9 +5693,9 @@
           <a:p>
             <a:pPr>
               <a:spcAft>
-                <a:spcPts val="800"/>
+                <a:spcPts val="400"/>
               </a:spcAft>
-              <a:defRPr sz="1300">
+              <a:defRPr sz="1100">
                 <a:solidFill>
                   <a:srgbClr val="94A3B8"/>
                 </a:solidFill>
@@ -5655,15 +5703,15 @@
               </a:defRPr>
             </a:pPr>
             <a:r>
-              <a:t>  - 유클리드 거리를 사용해 DB 내 932명 중 나와 가장 성격이 비슷한 3명의 실제 유저 자동 추적 매칭</a:t>
+              <a:t>  - 유클리드 거리 기준으로 DB 내 나와 지표가 가장 근접한 실제 유저 3명 자동 추적 매칭</a:t>
             </a:r>
           </a:p>
           <a:p>
             <a:pPr>
               <a:spcAft>
-                <a:spcPts val="800"/>
+                <a:spcPts val="400"/>
               </a:spcAft>
-              <a:defRPr sz="1300" b="1">
+              <a:defRPr sz="1100" b="1">
                 <a:solidFill>
                   <a:srgbClr val="FFFFFF"/>
                 </a:solidFill>
@@ -5671,15 +5719,15 @@
               </a:defRPr>
             </a:pPr>
             <a:r>
-              <a:t>  - 의사결정 활용: 유저가 자신의 VPIP, PFR, AF를 조정했을 때 매칭 유저 3인의 30세션 누적 자산 추이 대조 렌더링</a:t>
+              <a:t>  - 의사결정 활용: VPIP, PFR, AF 조정 시 매칭 유저의 30세션 누적 자산 추이 대조 렌더링</a:t>
             </a:r>
           </a:p>
           <a:p>
             <a:pPr>
               <a:spcAft>
-                <a:spcPts val="800"/>
+                <a:spcPts val="400"/>
               </a:spcAft>
-              <a:defRPr sz="1300" b="1">
+              <a:defRPr sz="1100" b="1">
                 <a:solidFill>
                   <a:srgbClr val="FFFFFF"/>
                 </a:solidFill>
@@ -5687,7 +5735,7 @@
               </a:defRPr>
             </a:pPr>
             <a:r>
-              <a:t>  - 효과: 유저가 무리한 베팅(Loose-Passive)을 고치지 않으면 몇 판 뒤 파산(이탈)할 확률을 시계열로 직접 모의실험하도록 하여 플레이 전략 개선 유도</a:t>
+              <a:t>  - 비즈니스 임팩트: 무리한 베팅(Loose-Passive) 습관이 미래 자산 파산에 미치는 영향을 모의실험하게 유도해 유저 행동 개선 자극</a:t>
             </a:r>
           </a:p>
         </p:txBody>
@@ -5708,7 +5756,7 @@
         </p:blipFill>
         <p:spPr>
           <a:xfrm>
-            <a:off x="6309360" y="1645920"/>
+            <a:off x="6309360" y="1371600"/>
             <a:ext cx="5120640" cy="3840480"/>
           </a:xfrm>
           <a:prstGeom prst="rect">
@@ -5822,8 +5870,8 @@
         </p:nvSpPr>
         <p:spPr>
           <a:xfrm>
-            <a:off x="731520" y="1645920"/>
-            <a:ext cx="5120640" cy="4389120"/>
+            <a:off x="731520" y="1371600"/>
+            <a:ext cx="5120640" cy="4754880"/>
           </a:xfrm>
           <a:prstGeom prst="roundRect">
             <a:avLst/>
@@ -5867,8 +5915,8 @@
         </p:nvSpPr>
         <p:spPr>
           <a:xfrm>
-            <a:off x="1005840" y="1920240"/>
-            <a:ext cx="4572000" cy="3840480"/>
+            <a:off x="960120" y="1600200"/>
+            <a:ext cx="4663440" cy="4297680"/>
           </a:xfrm>
           <a:prstGeom prst="rect">
             <a:avLst/>
@@ -5883,9 +5931,9 @@
           <a:p>
             <a:pPr>
               <a:spcAft>
-                <a:spcPts val="1400"/>
+                <a:spcPts val="1000"/>
               </a:spcAft>
-              <a:defRPr sz="1800" b="1">
+              <a:defRPr sz="1600" b="1">
                 <a:solidFill>
                   <a:srgbClr val="14B8A6"/>
                 </a:solidFill>
@@ -5899,9 +5947,9 @@
           <a:p>
             <a:pPr>
               <a:spcAft>
-                <a:spcPts val="800"/>
+                <a:spcPts val="400"/>
               </a:spcAft>
-              <a:defRPr sz="1300">
+              <a:defRPr sz="1100">
                 <a:solidFill>
                   <a:srgbClr val="94A3B8"/>
                 </a:solidFill>
@@ -5915,9 +5963,9 @@
           <a:p>
             <a:pPr>
               <a:spcAft>
-                <a:spcPts val="800"/>
+                <a:spcPts val="400"/>
               </a:spcAft>
-              <a:defRPr sz="1300" b="1">
+              <a:defRPr sz="1100" b="1">
                 <a:solidFill>
                   <a:srgbClr val="FFFFFF"/>
                 </a:solidFill>
@@ -5931,9 +5979,9 @@
           <a:p>
             <a:pPr>
               <a:spcAft>
-                <a:spcPts val="800"/>
+                <a:spcPts val="400"/>
               </a:spcAft>
-              <a:defRPr sz="1300" b="1">
+              <a:defRPr sz="1100" b="1">
                 <a:solidFill>
                   <a:srgbClr val="FFFFFF"/>
                 </a:solidFill>
@@ -5947,9 +5995,9 @@
           <a:p>
             <a:pPr>
               <a:spcAft>
-                <a:spcPts val="800"/>
+                <a:spcPts val="400"/>
               </a:spcAft>
-              <a:defRPr sz="1300">
+              <a:defRPr sz="1100">
                 <a:solidFill>
                   <a:srgbClr val="94A3B8"/>
                 </a:solidFill>
@@ -5960,9 +6008,9 @@
           <a:p>
             <a:pPr>
               <a:spcAft>
-                <a:spcPts val="800"/>
+                <a:spcPts val="400"/>
               </a:spcAft>
-              <a:defRPr sz="1300">
+              <a:defRPr sz="1100">
                 <a:solidFill>
                   <a:srgbClr val="94A3B8"/>
                 </a:solidFill>
@@ -5970,15 +6018,15 @@
               </a:defRPr>
             </a:pPr>
             <a:r>
-              <a:t>■ 개선이 필요한 점 및 향후 계획 (Roadmap)</a:t>
+              <a:t>■ 개선 필요 사항 및 향후 계획 (Roadmap)</a:t>
             </a:r>
           </a:p>
           <a:p>
             <a:pPr>
               <a:spcAft>
-                <a:spcPts val="800"/>
+                <a:spcPts val="400"/>
               </a:spcAft>
-              <a:defRPr sz="1300" b="1">
+              <a:defRPr sz="1100" b="1">
                 <a:solidFill>
                   <a:srgbClr val="FFFFFF"/>
                 </a:solidFill>
@@ -5992,9 +6040,9 @@
           <a:p>
             <a:pPr>
               <a:spcAft>
-                <a:spcPts val="800"/>
+                <a:spcPts val="400"/>
               </a:spcAft>
-              <a:defRPr sz="1300" b="1">
+              <a:defRPr sz="1100" b="1">
                 <a:solidFill>
                   <a:srgbClr val="FFFFFF"/>
                 </a:solidFill>
@@ -6023,7 +6071,7 @@
         </p:blipFill>
         <p:spPr>
           <a:xfrm>
-            <a:off x="6309360" y="1645920"/>
+            <a:off x="6309360" y="1371600"/>
             <a:ext cx="5120640" cy="3840480"/>
           </a:xfrm>
           <a:prstGeom prst="rect">

</xml_diff>